<commit_message>
Add deterministic Alpha Plans and inert procurement sandbox
</commit_message>
<xml_diff>
--- a/docs/presentations/AIGC_SYSTEM_ATLAS_V1.pptx
+++ b/docs/presentations/AIGC_SYSTEM_ATLAS_V1.pptx
@@ -2,25 +2,25 @@
 <file path=ppt/presentation.xml><?xml version="1.0" encoding="utf-8"?>
 <p:presentation xmlns:p="http://schemas.openxmlformats.org/presentationml/2006/main">
   <p:sldMasterIdLst>
-    <p:sldMasterId xmlns:r="http://schemas.openxmlformats.org/officeDocument/2006/relationships" id="2147483648" r:id="R2ec9907c8ec042db"/>
+    <p:sldMasterId xmlns:r="http://schemas.openxmlformats.org/officeDocument/2006/relationships" id="2147483648" r:id="Rc56fee58918847bc"/>
   </p:sldMasterIdLst>
   <p:notesMasterIdLst>
-    <p:notesMasterId xmlns:r="http://schemas.openxmlformats.org/officeDocument/2006/relationships" r:id="Rda12099166e84da3"/>
+    <p:notesMasterId xmlns:r="http://schemas.openxmlformats.org/officeDocument/2006/relationships" r:id="Re405992dd2884ca2"/>
   </p:notesMasterIdLst>
   <p:sldIdLst>
-    <p:sldId xmlns:r="http://schemas.openxmlformats.org/officeDocument/2006/relationships" id="256" r:id="R31296af0b8d841aa"/>
-    <p:sldId xmlns:r="http://schemas.openxmlformats.org/officeDocument/2006/relationships" id="257" r:id="Rcc31dc80af634abb"/>
-    <p:sldId xmlns:r="http://schemas.openxmlformats.org/officeDocument/2006/relationships" id="258" r:id="Rc79494e774574b8e"/>
-    <p:sldId xmlns:r="http://schemas.openxmlformats.org/officeDocument/2006/relationships" id="259" r:id="R5d2f80a16a8542ef"/>
-    <p:sldId xmlns:r="http://schemas.openxmlformats.org/officeDocument/2006/relationships" id="260" r:id="R6c31cabdf34f4e93"/>
-    <p:sldId xmlns:r="http://schemas.openxmlformats.org/officeDocument/2006/relationships" id="261" r:id="Rb0cc127ca8054658"/>
-    <p:sldId xmlns:r="http://schemas.openxmlformats.org/officeDocument/2006/relationships" id="262" r:id="R1c434aa5a9b849b8"/>
-    <p:sldId xmlns:r="http://schemas.openxmlformats.org/officeDocument/2006/relationships" id="263" r:id="R29a01e1a963d4166"/>
-    <p:sldId xmlns:r="http://schemas.openxmlformats.org/officeDocument/2006/relationships" id="264" r:id="R8f3007977d9b4b5b"/>
-    <p:sldId xmlns:r="http://schemas.openxmlformats.org/officeDocument/2006/relationships" id="265" r:id="Raf616dc7caca4265"/>
-    <p:sldId xmlns:r="http://schemas.openxmlformats.org/officeDocument/2006/relationships" id="266" r:id="Rc39572b07eb1419a"/>
-    <p:sldId xmlns:r="http://schemas.openxmlformats.org/officeDocument/2006/relationships" id="267" r:id="Ra395a4620246459f"/>
-    <p:sldId xmlns:r="http://schemas.openxmlformats.org/officeDocument/2006/relationships" id="268" r:id="Re16ec9f9284e4f9d"/>
+    <p:sldId xmlns:r="http://schemas.openxmlformats.org/officeDocument/2006/relationships" id="256" r:id="R6307643f1961448f"/>
+    <p:sldId xmlns:r="http://schemas.openxmlformats.org/officeDocument/2006/relationships" id="257" r:id="Rc286abf1d1004e9f"/>
+    <p:sldId xmlns:r="http://schemas.openxmlformats.org/officeDocument/2006/relationships" id="258" r:id="R48f7040bd5ba4524"/>
+    <p:sldId xmlns:r="http://schemas.openxmlformats.org/officeDocument/2006/relationships" id="259" r:id="R4ab4c0e00f3d4619"/>
+    <p:sldId xmlns:r="http://schemas.openxmlformats.org/officeDocument/2006/relationships" id="260" r:id="Rc4215c07f8404907"/>
+    <p:sldId xmlns:r="http://schemas.openxmlformats.org/officeDocument/2006/relationships" id="261" r:id="R345203a425624086"/>
+    <p:sldId xmlns:r="http://schemas.openxmlformats.org/officeDocument/2006/relationships" id="262" r:id="Racfb514b84ac43ab"/>
+    <p:sldId xmlns:r="http://schemas.openxmlformats.org/officeDocument/2006/relationships" id="263" r:id="Rfa41ca6fbe954e70"/>
+    <p:sldId xmlns:r="http://schemas.openxmlformats.org/officeDocument/2006/relationships" id="264" r:id="Rdf742faebc6a4a90"/>
+    <p:sldId xmlns:r="http://schemas.openxmlformats.org/officeDocument/2006/relationships" id="265" r:id="R9a3c616c574b4590"/>
+    <p:sldId xmlns:r="http://schemas.openxmlformats.org/officeDocument/2006/relationships" id="266" r:id="R0fdf1810bea840ff"/>
+    <p:sldId xmlns:r="http://schemas.openxmlformats.org/officeDocument/2006/relationships" id="267" r:id="Rde94213fe364456e"/>
+    <p:sldId xmlns:r="http://schemas.openxmlformats.org/officeDocument/2006/relationships" id="268" r:id="Ra9ba967fbe3d4a9d"/>
   </p:sldIdLst>
   <p:sldSz cx="12192000" cy="6858000"/>
   <p:notesSz cx="6858000" cy="9144000"/>
@@ -1587,7 +1587,7 @@
   </p:cSld>
   <p:clrMap bg1="lt1" tx1="dk1" bg2="lt2" tx2="dk2" accent1="accent1" accent2="accent2" accent3="accent3" accent4="accent4" accent5="accent5" accent6="accent6" hlink="hlink" folHlink="folHlink"/>
   <p:sldLayoutIdLst>
-    <p:sldLayoutId xmlns:r="http://schemas.openxmlformats.org/officeDocument/2006/relationships" id="2147483649" r:id="Ree181b6234014fd3"/>
+    <p:sldLayoutId xmlns:r="http://schemas.openxmlformats.org/officeDocument/2006/relationships" id="2147483649" r:id="Rfd0e455498b641ee"/>
   </p:sldLayoutIdLst>
   <p:txStyles>
     <p:titleStyle>
@@ -2486,6 +2486,7 @@
           <a:lstStyle xmlns:a="http://schemas.openxmlformats.org/drawingml/2006/main"/>
           <a:p xmlns:a="http://schemas.openxmlformats.org/drawingml/2006/main">
             <a:pPr algn="l">
+              <a:buNone/>
               <a:defRPr sz="4800" b="1">
                 <a:solidFill>
                   <a:srgbClr val="EAFBFF"/>
@@ -2536,6 +2537,7 @@
           <a:lstStyle xmlns:a="http://schemas.openxmlformats.org/drawingml/2006/main"/>
           <a:p xmlns:a="http://schemas.openxmlformats.org/drawingml/2006/main">
             <a:pPr algn="l">
+              <a:buNone/>
               <a:defRPr sz="3900" b="1">
                 <a:solidFill>
                   <a:srgbClr val="23D7E6"/>
@@ -2586,6 +2588,7 @@
           <a:lstStyle xmlns:a="http://schemas.openxmlformats.org/drawingml/2006/main"/>
           <a:p xmlns:a="http://schemas.openxmlformats.org/drawingml/2006/main">
             <a:pPr algn="l">
+              <a:buNone/>
               <a:defRPr sz="1800" b="0">
                 <a:solidFill>
                   <a:srgbClr val="9DB7C2"/>
@@ -2636,6 +2639,7 @@
           <a:lstStyle xmlns:a="http://schemas.openxmlformats.org/drawingml/2006/main"/>
           <a:p xmlns:a="http://schemas.openxmlformats.org/drawingml/2006/main">
             <a:pPr algn="l">
+              <a:buNone/>
               <a:defRPr sz="1350" b="1">
                 <a:solidFill>
                   <a:srgbClr val="EAFBFF"/>
@@ -2686,6 +2690,7 @@
           <a:lstStyle xmlns:a="http://schemas.openxmlformats.org/drawingml/2006/main"/>
           <a:p xmlns:a="http://schemas.openxmlformats.org/drawingml/2006/main">
             <a:pPr algn="l">
+              <a:buNone/>
               <a:defRPr sz="1800" b="0">
                 <a:solidFill>
                   <a:srgbClr val="EAFBFF"/>
@@ -2736,6 +2741,7 @@
           <a:lstStyle xmlns:a="http://schemas.openxmlformats.org/drawingml/2006/main"/>
           <a:p xmlns:a="http://schemas.openxmlformats.org/drawingml/2006/main">
             <a:pPr algn="l">
+              <a:buNone/>
               <a:defRPr sz="975" b="1">
                 <a:solidFill>
                   <a:srgbClr val="617984"/>
@@ -2815,6 +2821,7 @@
           <a:lstStyle xmlns:a="http://schemas.openxmlformats.org/drawingml/2006/main"/>
           <a:p xmlns:a="http://schemas.openxmlformats.org/drawingml/2006/main">
             <a:pPr algn="l">
+              <a:buNone/>
               <a:defRPr sz="900" b="1">
                 <a:solidFill>
                   <a:srgbClr val="23D7E6"/>
@@ -2865,6 +2872,7 @@
           <a:lstStyle xmlns:a="http://schemas.openxmlformats.org/drawingml/2006/main"/>
           <a:p xmlns:a="http://schemas.openxmlformats.org/drawingml/2006/main">
             <a:pPr algn="l">
+              <a:buNone/>
               <a:defRPr sz="2700" b="1">
                 <a:solidFill>
                   <a:srgbClr val="EAFBFF"/>
@@ -3148,6 +3156,7 @@
           <a:lstStyle xmlns:a="http://schemas.openxmlformats.org/drawingml/2006/main"/>
           <a:p xmlns:a="http://schemas.openxmlformats.org/drawingml/2006/main">
             <a:pPr algn="l">
+              <a:buNone/>
               <a:defRPr sz="1350" b="1">
                 <a:solidFill>
                   <a:srgbClr val="EAFBFF"/>
@@ -3198,6 +3207,7 @@
           <a:lstStyle xmlns:a="http://schemas.openxmlformats.org/drawingml/2006/main"/>
           <a:p xmlns:a="http://schemas.openxmlformats.org/drawingml/2006/main">
             <a:pPr algn="l">
+              <a:buNone/>
               <a:defRPr sz="1050" b="0">
                 <a:solidFill>
                   <a:srgbClr val="9DB7C2"/>
@@ -3283,6 +3293,7 @@
           <a:lstStyle xmlns:a="http://schemas.openxmlformats.org/drawingml/2006/main"/>
           <a:p xmlns:a="http://schemas.openxmlformats.org/drawingml/2006/main">
             <a:pPr algn="l">
+              <a:buNone/>
               <a:defRPr sz="1350" b="1">
                 <a:solidFill>
                   <a:srgbClr val="EAFBFF"/>
@@ -3333,6 +3344,7 @@
           <a:lstStyle xmlns:a="http://schemas.openxmlformats.org/drawingml/2006/main"/>
           <a:p xmlns:a="http://schemas.openxmlformats.org/drawingml/2006/main">
             <a:pPr algn="l">
+              <a:buNone/>
               <a:defRPr sz="1050" b="0">
                 <a:solidFill>
                   <a:srgbClr val="9DB7C2"/>
@@ -3418,6 +3430,7 @@
           <a:lstStyle xmlns:a="http://schemas.openxmlformats.org/drawingml/2006/main"/>
           <a:p xmlns:a="http://schemas.openxmlformats.org/drawingml/2006/main">
             <a:pPr algn="l">
+              <a:buNone/>
               <a:defRPr sz="1350" b="1">
                 <a:solidFill>
                   <a:srgbClr val="EAFBFF"/>
@@ -3468,6 +3481,7 @@
           <a:lstStyle xmlns:a="http://schemas.openxmlformats.org/drawingml/2006/main"/>
           <a:p xmlns:a="http://schemas.openxmlformats.org/drawingml/2006/main">
             <a:pPr algn="l">
+              <a:buNone/>
               <a:defRPr sz="1050" b="0">
                 <a:solidFill>
                   <a:srgbClr val="9DB7C2"/>
@@ -3553,6 +3567,7 @@
           <a:lstStyle xmlns:a="http://schemas.openxmlformats.org/drawingml/2006/main"/>
           <a:p xmlns:a="http://schemas.openxmlformats.org/drawingml/2006/main">
             <a:pPr algn="l">
+              <a:buNone/>
               <a:defRPr sz="1350" b="1">
                 <a:solidFill>
                   <a:srgbClr val="EAFBFF"/>
@@ -3603,6 +3618,7 @@
           <a:lstStyle xmlns:a="http://schemas.openxmlformats.org/drawingml/2006/main"/>
           <a:p xmlns:a="http://schemas.openxmlformats.org/drawingml/2006/main">
             <a:pPr algn="l">
+              <a:buNone/>
               <a:defRPr sz="1050" b="0">
                 <a:solidFill>
                   <a:srgbClr val="9DB7C2"/>
@@ -3688,6 +3704,7 @@
           <a:lstStyle xmlns:a="http://schemas.openxmlformats.org/drawingml/2006/main"/>
           <a:p xmlns:a="http://schemas.openxmlformats.org/drawingml/2006/main">
             <a:pPr algn="l">
+              <a:buNone/>
               <a:defRPr sz="1350" b="1">
                 <a:solidFill>
                   <a:srgbClr val="EAFBFF"/>
@@ -3738,6 +3755,7 @@
           <a:lstStyle xmlns:a="http://schemas.openxmlformats.org/drawingml/2006/main"/>
           <a:p xmlns:a="http://schemas.openxmlformats.org/drawingml/2006/main">
             <a:pPr algn="l">
+              <a:buNone/>
               <a:defRPr sz="1050" b="0">
                 <a:solidFill>
                   <a:srgbClr val="9DB7C2"/>
@@ -3823,6 +3841,7 @@
           <a:lstStyle xmlns:a="http://schemas.openxmlformats.org/drawingml/2006/main"/>
           <a:p xmlns:a="http://schemas.openxmlformats.org/drawingml/2006/main">
             <a:pPr algn="l">
+              <a:buNone/>
               <a:defRPr sz="1350" b="1">
                 <a:solidFill>
                   <a:srgbClr val="EAFBFF"/>
@@ -3873,6 +3892,7 @@
           <a:lstStyle xmlns:a="http://schemas.openxmlformats.org/drawingml/2006/main"/>
           <a:p xmlns:a="http://schemas.openxmlformats.org/drawingml/2006/main">
             <a:pPr algn="l">
+              <a:buNone/>
               <a:defRPr sz="1050" b="0">
                 <a:solidFill>
                   <a:srgbClr val="9DB7C2"/>
@@ -3923,6 +3943,7 @@
           <a:lstStyle xmlns:a="http://schemas.openxmlformats.org/drawingml/2006/main"/>
           <a:p xmlns:a="http://schemas.openxmlformats.org/drawingml/2006/main">
             <a:pPr algn="ctr">
+              <a:buNone/>
               <a:defRPr sz="3300" b="1">
                 <a:solidFill>
                   <a:srgbClr val="23D7E6"/>
@@ -3973,6 +3994,7 @@
           <a:lstStyle xmlns:a="http://schemas.openxmlformats.org/drawingml/2006/main"/>
           <a:p xmlns:a="http://schemas.openxmlformats.org/drawingml/2006/main">
             <a:pPr algn="ctr">
+              <a:buNone/>
               <a:defRPr sz="1200" b="1">
                 <a:solidFill>
                   <a:srgbClr val="9DB7C2"/>
@@ -4023,6 +4045,7 @@
           <a:lstStyle xmlns:a="http://schemas.openxmlformats.org/drawingml/2006/main"/>
           <a:p xmlns:a="http://schemas.openxmlformats.org/drawingml/2006/main">
             <a:pPr algn="ctr">
+              <a:buNone/>
               <a:defRPr sz="3300" b="1">
                 <a:solidFill>
                   <a:srgbClr val="23D7E6"/>
@@ -4073,6 +4096,7 @@
           <a:lstStyle xmlns:a="http://schemas.openxmlformats.org/drawingml/2006/main"/>
           <a:p xmlns:a="http://schemas.openxmlformats.org/drawingml/2006/main">
             <a:pPr algn="ctr">
+              <a:buNone/>
               <a:defRPr sz="1200" b="1">
                 <a:solidFill>
                   <a:srgbClr val="9DB7C2"/>
@@ -4123,6 +4147,7 @@
           <a:lstStyle xmlns:a="http://schemas.openxmlformats.org/drawingml/2006/main"/>
           <a:p xmlns:a="http://schemas.openxmlformats.org/drawingml/2006/main">
             <a:pPr algn="ctr">
+              <a:buNone/>
               <a:defRPr sz="3300" b="1">
                 <a:solidFill>
                   <a:srgbClr val="23D7E6"/>
@@ -4173,6 +4198,7 @@
           <a:lstStyle xmlns:a="http://schemas.openxmlformats.org/drawingml/2006/main"/>
           <a:p xmlns:a="http://schemas.openxmlformats.org/drawingml/2006/main">
             <a:pPr algn="ctr">
+              <a:buNone/>
               <a:defRPr sz="1200" b="1">
                 <a:solidFill>
                   <a:srgbClr val="9DB7C2"/>
@@ -4223,6 +4249,7 @@
           <a:lstStyle xmlns:a="http://schemas.openxmlformats.org/drawingml/2006/main"/>
           <a:p xmlns:a="http://schemas.openxmlformats.org/drawingml/2006/main">
             <a:pPr algn="ctr">
+              <a:buNone/>
               <a:defRPr sz="1350" b="1">
                 <a:solidFill>
                   <a:srgbClr val="F8B84E"/>
@@ -4273,6 +4300,7 @@
           <a:lstStyle xmlns:a="http://schemas.openxmlformats.org/drawingml/2006/main"/>
           <a:p xmlns:a="http://schemas.openxmlformats.org/drawingml/2006/main">
             <a:pPr algn="l">
+              <a:buNone/>
               <a:defRPr sz="750" b="1">
                 <a:solidFill>
                   <a:srgbClr val="617984"/>
@@ -4323,6 +4351,7 @@
           <a:lstStyle xmlns:a="http://schemas.openxmlformats.org/drawingml/2006/main"/>
           <a:p xmlns:a="http://schemas.openxmlformats.org/drawingml/2006/main">
             <a:pPr algn="r">
+              <a:buNone/>
               <a:defRPr sz="750" b="1">
                 <a:solidFill>
                   <a:srgbClr val="617984"/>
@@ -4402,6 +4431,7 @@
           <a:lstStyle xmlns:a="http://schemas.openxmlformats.org/drawingml/2006/main"/>
           <a:p xmlns:a="http://schemas.openxmlformats.org/drawingml/2006/main">
             <a:pPr algn="l">
+              <a:buNone/>
               <a:defRPr sz="900" b="1">
                 <a:solidFill>
                   <a:srgbClr val="23D7E6"/>
@@ -4452,6 +4482,7 @@
           <a:lstStyle xmlns:a="http://schemas.openxmlformats.org/drawingml/2006/main"/>
           <a:p xmlns:a="http://schemas.openxmlformats.org/drawingml/2006/main">
             <a:pPr algn="l">
+              <a:buNone/>
               <a:defRPr sz="2700" b="1">
                 <a:solidFill>
                   <a:srgbClr val="EAFBFF"/>
@@ -4535,6 +4566,7 @@
           <a:lstStyle xmlns:a="http://schemas.openxmlformats.org/drawingml/2006/main"/>
           <a:p xmlns:a="http://schemas.openxmlformats.org/drawingml/2006/main">
             <a:pPr algn="ctr">
+              <a:buNone/>
               <a:defRPr sz="4350" b="1">
                 <a:solidFill>
                   <a:srgbClr val="1AAE9F"/>
@@ -4585,6 +4617,7 @@
           <a:lstStyle xmlns:a="http://schemas.openxmlformats.org/drawingml/2006/main"/>
           <a:p xmlns:a="http://schemas.openxmlformats.org/drawingml/2006/main">
             <a:pPr algn="ctr">
+              <a:buNone/>
               <a:defRPr sz="1350" b="1">
                 <a:solidFill>
                   <a:srgbClr val="EAFBFF"/>
@@ -4635,6 +4668,7 @@
           <a:lstStyle xmlns:a="http://schemas.openxmlformats.org/drawingml/2006/main"/>
           <a:p xmlns:a="http://schemas.openxmlformats.org/drawingml/2006/main">
             <a:pPr algn="ctr">
+              <a:buNone/>
               <a:defRPr sz="1125" b="0">
                 <a:solidFill>
                   <a:srgbClr val="9DB7C2"/>
@@ -4720,6 +4754,7 @@
           <a:lstStyle xmlns:a="http://schemas.openxmlformats.org/drawingml/2006/main"/>
           <a:p xmlns:a="http://schemas.openxmlformats.org/drawingml/2006/main">
             <a:pPr algn="ctr">
+              <a:buNone/>
               <a:defRPr sz="2025" b="1">
                 <a:solidFill>
                   <a:srgbClr val="061521"/>
@@ -4770,6 +4805,7 @@
           <a:lstStyle xmlns:a="http://schemas.openxmlformats.org/drawingml/2006/main"/>
           <a:p xmlns:a="http://schemas.openxmlformats.org/drawingml/2006/main">
             <a:pPr algn="ctr">
+              <a:buNone/>
               <a:defRPr sz="1275" b="1">
                 <a:solidFill>
                   <a:srgbClr val="EAFBFF"/>
@@ -4855,6 +4891,7 @@
           <a:lstStyle xmlns:a="http://schemas.openxmlformats.org/drawingml/2006/main"/>
           <a:p xmlns:a="http://schemas.openxmlformats.org/drawingml/2006/main">
             <a:pPr algn="ctr">
+              <a:buNone/>
               <a:defRPr sz="2025" b="1">
                 <a:solidFill>
                   <a:srgbClr val="061521"/>
@@ -4905,6 +4942,7 @@
           <a:lstStyle xmlns:a="http://schemas.openxmlformats.org/drawingml/2006/main"/>
           <a:p xmlns:a="http://schemas.openxmlformats.org/drawingml/2006/main">
             <a:pPr algn="ctr">
+              <a:buNone/>
               <a:defRPr sz="1275" b="1">
                 <a:solidFill>
                   <a:srgbClr val="EAFBFF"/>
@@ -4955,6 +4993,7 @@
           <a:lstStyle xmlns:a="http://schemas.openxmlformats.org/drawingml/2006/main"/>
           <a:p xmlns:a="http://schemas.openxmlformats.org/drawingml/2006/main">
             <a:pPr algn="ctr">
+              <a:buNone/>
               <a:defRPr sz="1275" b="1">
                 <a:solidFill>
                   <a:srgbClr val="F8B84E"/>
@@ -5005,6 +5044,7 @@
           <a:lstStyle xmlns:a="http://schemas.openxmlformats.org/drawingml/2006/main"/>
           <a:p xmlns:a="http://schemas.openxmlformats.org/drawingml/2006/main">
             <a:pPr algn="l">
+              <a:buNone/>
               <a:defRPr sz="750" b="1">
                 <a:solidFill>
                   <a:srgbClr val="617984"/>
@@ -5055,6 +5095,7 @@
           <a:lstStyle xmlns:a="http://schemas.openxmlformats.org/drawingml/2006/main"/>
           <a:p xmlns:a="http://schemas.openxmlformats.org/drawingml/2006/main">
             <a:pPr algn="r">
+              <a:buNone/>
               <a:defRPr sz="750" b="1">
                 <a:solidFill>
                   <a:srgbClr val="617984"/>
@@ -5134,6 +5175,7 @@
           <a:lstStyle xmlns:a="http://schemas.openxmlformats.org/drawingml/2006/main"/>
           <a:p xmlns:a="http://schemas.openxmlformats.org/drawingml/2006/main">
             <a:pPr algn="l">
+              <a:buNone/>
               <a:defRPr sz="900" b="1">
                 <a:solidFill>
                   <a:srgbClr val="23D7E6"/>
@@ -5184,6 +5226,7 @@
           <a:lstStyle xmlns:a="http://schemas.openxmlformats.org/drawingml/2006/main"/>
           <a:p xmlns:a="http://schemas.openxmlformats.org/drawingml/2006/main">
             <a:pPr algn="l">
+              <a:buNone/>
               <a:defRPr sz="2700" b="1">
                 <a:solidFill>
                   <a:srgbClr val="EAFBFF"/>
@@ -5267,6 +5310,7 @@
           <a:lstStyle xmlns:a="http://schemas.openxmlformats.org/drawingml/2006/main"/>
           <a:p xmlns:a="http://schemas.openxmlformats.org/drawingml/2006/main">
             <a:pPr algn="l">
+              <a:buNone/>
               <a:defRPr sz="1350" b="1">
                 <a:solidFill>
                   <a:srgbClr val="23D7E6"/>
@@ -5317,6 +5361,7 @@
           <a:lstStyle xmlns:a="http://schemas.openxmlformats.org/drawingml/2006/main"/>
           <a:p xmlns:a="http://schemas.openxmlformats.org/drawingml/2006/main">
             <a:pPr algn="l">
+              <a:buNone/>
               <a:defRPr sz="1200" b="0">
                 <a:solidFill>
                   <a:srgbClr val="EAFBFF"/>
@@ -5400,6 +5445,7 @@
           <a:lstStyle xmlns:a="http://schemas.openxmlformats.org/drawingml/2006/main"/>
           <a:p xmlns:a="http://schemas.openxmlformats.org/drawingml/2006/main">
             <a:pPr algn="l">
+              <a:buNone/>
               <a:defRPr sz="1350" b="1">
                 <a:solidFill>
                   <a:srgbClr val="23D7E6"/>
@@ -5450,6 +5496,7 @@
           <a:lstStyle xmlns:a="http://schemas.openxmlformats.org/drawingml/2006/main"/>
           <a:p xmlns:a="http://schemas.openxmlformats.org/drawingml/2006/main">
             <a:pPr algn="l">
+              <a:buNone/>
               <a:defRPr sz="1200" b="0">
                 <a:solidFill>
                   <a:srgbClr val="EAFBFF"/>
@@ -5533,6 +5580,7 @@
           <a:lstStyle xmlns:a="http://schemas.openxmlformats.org/drawingml/2006/main"/>
           <a:p xmlns:a="http://schemas.openxmlformats.org/drawingml/2006/main">
             <a:pPr algn="l">
+              <a:buNone/>
               <a:defRPr sz="1350" b="1">
                 <a:solidFill>
                   <a:srgbClr val="23D7E6"/>
@@ -5583,6 +5631,7 @@
           <a:lstStyle xmlns:a="http://schemas.openxmlformats.org/drawingml/2006/main"/>
           <a:p xmlns:a="http://schemas.openxmlformats.org/drawingml/2006/main">
             <a:pPr algn="l">
+              <a:buNone/>
               <a:defRPr sz="1200" b="0">
                 <a:solidFill>
                   <a:srgbClr val="EAFBFF"/>
@@ -5666,6 +5715,7 @@
           <a:lstStyle xmlns:a="http://schemas.openxmlformats.org/drawingml/2006/main"/>
           <a:p xmlns:a="http://schemas.openxmlformats.org/drawingml/2006/main">
             <a:pPr algn="l">
+              <a:buNone/>
               <a:defRPr sz="1350" b="1">
                 <a:solidFill>
                   <a:srgbClr val="23D7E6"/>
@@ -5716,6 +5766,7 @@
           <a:lstStyle xmlns:a="http://schemas.openxmlformats.org/drawingml/2006/main"/>
           <a:p xmlns:a="http://schemas.openxmlformats.org/drawingml/2006/main">
             <a:pPr algn="l">
+              <a:buNone/>
               <a:defRPr sz="1200" b="0">
                 <a:solidFill>
                   <a:srgbClr val="EAFBFF"/>
@@ -5799,6 +5850,7 @@
           <a:lstStyle xmlns:a="http://schemas.openxmlformats.org/drawingml/2006/main"/>
           <a:p xmlns:a="http://schemas.openxmlformats.org/drawingml/2006/main">
             <a:pPr algn="l">
+              <a:buNone/>
               <a:defRPr sz="1350" b="1">
                 <a:solidFill>
                   <a:srgbClr val="23D7E6"/>
@@ -5849,6 +5901,7 @@
           <a:lstStyle xmlns:a="http://schemas.openxmlformats.org/drawingml/2006/main"/>
           <a:p xmlns:a="http://schemas.openxmlformats.org/drawingml/2006/main">
             <a:pPr algn="l">
+              <a:buNone/>
               <a:defRPr sz="1200" b="0">
                 <a:solidFill>
                   <a:srgbClr val="EAFBFF"/>
@@ -5932,6 +5985,7 @@
           <a:lstStyle xmlns:a="http://schemas.openxmlformats.org/drawingml/2006/main"/>
           <a:p xmlns:a="http://schemas.openxmlformats.org/drawingml/2006/main">
             <a:pPr algn="l">
+              <a:buNone/>
               <a:defRPr sz="1350" b="1">
                 <a:solidFill>
                   <a:srgbClr val="23D7E6"/>
@@ -5982,6 +6036,7 @@
           <a:lstStyle xmlns:a="http://schemas.openxmlformats.org/drawingml/2006/main"/>
           <a:p xmlns:a="http://schemas.openxmlformats.org/drawingml/2006/main">
             <a:pPr algn="l">
+              <a:buNone/>
               <a:defRPr sz="1200" b="0">
                 <a:solidFill>
                   <a:srgbClr val="EAFBFF"/>
@@ -6065,6 +6120,7 @@
           <a:lstStyle xmlns:a="http://schemas.openxmlformats.org/drawingml/2006/main"/>
           <a:p xmlns:a="http://schemas.openxmlformats.org/drawingml/2006/main">
             <a:pPr algn="l">
+              <a:buNone/>
               <a:defRPr sz="1350" b="1">
                 <a:solidFill>
                   <a:srgbClr val="23D7E6"/>
@@ -6115,6 +6171,7 @@
           <a:lstStyle xmlns:a="http://schemas.openxmlformats.org/drawingml/2006/main"/>
           <a:p xmlns:a="http://schemas.openxmlformats.org/drawingml/2006/main">
             <a:pPr algn="l">
+              <a:buNone/>
               <a:defRPr sz="1200" b="0">
                 <a:solidFill>
                   <a:srgbClr val="EAFBFF"/>
@@ -6198,6 +6255,7 @@
           <a:lstStyle xmlns:a="http://schemas.openxmlformats.org/drawingml/2006/main"/>
           <a:p xmlns:a="http://schemas.openxmlformats.org/drawingml/2006/main">
             <a:pPr algn="l">
+              <a:buNone/>
               <a:defRPr sz="1350" b="1">
                 <a:solidFill>
                   <a:srgbClr val="23D7E6"/>
@@ -6248,6 +6306,7 @@
           <a:lstStyle xmlns:a="http://schemas.openxmlformats.org/drawingml/2006/main"/>
           <a:p xmlns:a="http://schemas.openxmlformats.org/drawingml/2006/main">
             <a:pPr algn="l">
+              <a:buNone/>
               <a:defRPr sz="1200" b="0">
                 <a:solidFill>
                   <a:srgbClr val="EAFBFF"/>
@@ -6331,6 +6390,7 @@
           <a:lstStyle xmlns:a="http://schemas.openxmlformats.org/drawingml/2006/main"/>
           <a:p xmlns:a="http://schemas.openxmlformats.org/drawingml/2006/main">
             <a:pPr algn="ctr">
+              <a:buNone/>
               <a:defRPr sz="1350" b="1">
                 <a:solidFill>
                   <a:srgbClr val="F8B84E"/>
@@ -6381,6 +6441,7 @@
           <a:lstStyle xmlns:a="http://schemas.openxmlformats.org/drawingml/2006/main"/>
           <a:p xmlns:a="http://schemas.openxmlformats.org/drawingml/2006/main">
             <a:pPr algn="l">
+              <a:buNone/>
               <a:defRPr sz="750" b="1">
                 <a:solidFill>
                   <a:srgbClr val="617984"/>
@@ -6431,6 +6492,7 @@
           <a:lstStyle xmlns:a="http://schemas.openxmlformats.org/drawingml/2006/main"/>
           <a:p xmlns:a="http://schemas.openxmlformats.org/drawingml/2006/main">
             <a:pPr algn="r">
+              <a:buNone/>
               <a:defRPr sz="750" b="1">
                 <a:solidFill>
                   <a:srgbClr val="617984"/>
@@ -6510,6 +6572,7 @@
           <a:lstStyle xmlns:a="http://schemas.openxmlformats.org/drawingml/2006/main"/>
           <a:p xmlns:a="http://schemas.openxmlformats.org/drawingml/2006/main">
             <a:pPr algn="l">
+              <a:buNone/>
               <a:defRPr sz="900" b="1">
                 <a:solidFill>
                   <a:srgbClr val="23D7E6"/>
@@ -6560,6 +6623,7 @@
           <a:lstStyle xmlns:a="http://schemas.openxmlformats.org/drawingml/2006/main"/>
           <a:p xmlns:a="http://schemas.openxmlformats.org/drawingml/2006/main">
             <a:pPr algn="l">
+              <a:buNone/>
               <a:defRPr sz="2700" b="1">
                 <a:solidFill>
                   <a:srgbClr val="EAFBFF"/>
@@ -6643,6 +6707,7 @@
           <a:lstStyle xmlns:a="http://schemas.openxmlformats.org/drawingml/2006/main"/>
           <a:p xmlns:a="http://schemas.openxmlformats.org/drawingml/2006/main">
             <a:pPr algn="ctr">
+              <a:buNone/>
               <a:defRPr sz="2550" b="1">
                 <a:solidFill>
                   <a:srgbClr val="23D7E6"/>
@@ -6693,6 +6758,7 @@
           <a:lstStyle xmlns:a="http://schemas.openxmlformats.org/drawingml/2006/main"/>
           <a:p xmlns:a="http://schemas.openxmlformats.org/drawingml/2006/main">
             <a:pPr algn="l">
+              <a:buNone/>
               <a:defRPr sz="1575" b="1">
                 <a:solidFill>
                   <a:srgbClr val="EAFBFF"/>
@@ -6743,6 +6809,7 @@
           <a:lstStyle xmlns:a="http://schemas.openxmlformats.org/drawingml/2006/main"/>
           <a:p xmlns:a="http://schemas.openxmlformats.org/drawingml/2006/main">
             <a:pPr algn="l">
+              <a:buNone/>
               <a:defRPr sz="1200" b="0">
                 <a:solidFill>
                   <a:srgbClr val="9DB7C2"/>
@@ -6826,6 +6893,7 @@
           <a:lstStyle xmlns:a="http://schemas.openxmlformats.org/drawingml/2006/main"/>
           <a:p xmlns:a="http://schemas.openxmlformats.org/drawingml/2006/main">
             <a:pPr algn="ctr">
+              <a:buNone/>
               <a:defRPr sz="2550" b="1">
                 <a:solidFill>
                   <a:srgbClr val="617984"/>
@@ -6876,6 +6944,7 @@
           <a:lstStyle xmlns:a="http://schemas.openxmlformats.org/drawingml/2006/main"/>
           <a:p xmlns:a="http://schemas.openxmlformats.org/drawingml/2006/main">
             <a:pPr algn="l">
+              <a:buNone/>
               <a:defRPr sz="1575" b="1">
                 <a:solidFill>
                   <a:srgbClr val="EAFBFF"/>
@@ -6926,6 +6995,7 @@
           <a:lstStyle xmlns:a="http://schemas.openxmlformats.org/drawingml/2006/main"/>
           <a:p xmlns:a="http://schemas.openxmlformats.org/drawingml/2006/main">
             <a:pPr algn="l">
+              <a:buNone/>
               <a:defRPr sz="1200" b="0">
                 <a:solidFill>
                   <a:srgbClr val="9DB7C2"/>
@@ -7009,6 +7079,7 @@
           <a:lstStyle xmlns:a="http://schemas.openxmlformats.org/drawingml/2006/main"/>
           <a:p xmlns:a="http://schemas.openxmlformats.org/drawingml/2006/main">
             <a:pPr algn="ctr">
+              <a:buNone/>
               <a:defRPr sz="2550" b="1">
                 <a:solidFill>
                   <a:srgbClr val="617984"/>
@@ -7059,6 +7130,7 @@
           <a:lstStyle xmlns:a="http://schemas.openxmlformats.org/drawingml/2006/main"/>
           <a:p xmlns:a="http://schemas.openxmlformats.org/drawingml/2006/main">
             <a:pPr algn="l">
+              <a:buNone/>
               <a:defRPr sz="1575" b="1">
                 <a:solidFill>
                   <a:srgbClr val="EAFBFF"/>
@@ -7109,6 +7181,7 @@
           <a:lstStyle xmlns:a="http://schemas.openxmlformats.org/drawingml/2006/main"/>
           <a:p xmlns:a="http://schemas.openxmlformats.org/drawingml/2006/main">
             <a:pPr algn="l">
+              <a:buNone/>
               <a:defRPr sz="1200" b="0">
                 <a:solidFill>
                   <a:srgbClr val="9DB7C2"/>
@@ -7192,6 +7265,7 @@
           <a:lstStyle xmlns:a="http://schemas.openxmlformats.org/drawingml/2006/main"/>
           <a:p xmlns:a="http://schemas.openxmlformats.org/drawingml/2006/main">
             <a:pPr algn="ctr">
+              <a:buNone/>
               <a:defRPr sz="2550" b="1">
                 <a:solidFill>
                   <a:srgbClr val="617984"/>
@@ -7242,6 +7316,7 @@
           <a:lstStyle xmlns:a="http://schemas.openxmlformats.org/drawingml/2006/main"/>
           <a:p xmlns:a="http://schemas.openxmlformats.org/drawingml/2006/main">
             <a:pPr algn="l">
+              <a:buNone/>
               <a:defRPr sz="1575" b="1">
                 <a:solidFill>
                   <a:srgbClr val="EAFBFF"/>
@@ -7292,6 +7367,7 @@
           <a:lstStyle xmlns:a="http://schemas.openxmlformats.org/drawingml/2006/main"/>
           <a:p xmlns:a="http://schemas.openxmlformats.org/drawingml/2006/main">
             <a:pPr algn="l">
+              <a:buNone/>
               <a:defRPr sz="1200" b="0">
                 <a:solidFill>
                   <a:srgbClr val="9DB7C2"/>
@@ -7375,6 +7451,7 @@
           <a:lstStyle xmlns:a="http://schemas.openxmlformats.org/drawingml/2006/main"/>
           <a:p xmlns:a="http://schemas.openxmlformats.org/drawingml/2006/main">
             <a:pPr algn="ctr">
+              <a:buNone/>
               <a:defRPr sz="2550" b="1">
                 <a:solidFill>
                   <a:srgbClr val="617984"/>
@@ -7425,6 +7502,7 @@
           <a:lstStyle xmlns:a="http://schemas.openxmlformats.org/drawingml/2006/main"/>
           <a:p xmlns:a="http://schemas.openxmlformats.org/drawingml/2006/main">
             <a:pPr algn="l">
+              <a:buNone/>
               <a:defRPr sz="1575" b="1">
                 <a:solidFill>
                   <a:srgbClr val="EAFBFF"/>
@@ -7475,6 +7553,7 @@
           <a:lstStyle xmlns:a="http://schemas.openxmlformats.org/drawingml/2006/main"/>
           <a:p xmlns:a="http://schemas.openxmlformats.org/drawingml/2006/main">
             <a:pPr algn="l">
+              <a:buNone/>
               <a:defRPr sz="1200" b="0">
                 <a:solidFill>
                   <a:srgbClr val="9DB7C2"/>
@@ -7525,6 +7604,7 @@
           <a:lstStyle xmlns:a="http://schemas.openxmlformats.org/drawingml/2006/main"/>
           <a:p xmlns:a="http://schemas.openxmlformats.org/drawingml/2006/main">
             <a:pPr algn="ctr">
+              <a:buNone/>
               <a:defRPr sz="1650" b="1">
                 <a:solidFill>
                   <a:srgbClr val="23D7E6"/>
@@ -7575,6 +7655,7 @@
           <a:lstStyle xmlns:a="http://schemas.openxmlformats.org/drawingml/2006/main"/>
           <a:p xmlns:a="http://schemas.openxmlformats.org/drawingml/2006/main">
             <a:pPr algn="l">
+              <a:buNone/>
               <a:defRPr sz="750" b="1">
                 <a:solidFill>
                   <a:srgbClr val="617984"/>
@@ -7625,6 +7706,7 @@
           <a:lstStyle xmlns:a="http://schemas.openxmlformats.org/drawingml/2006/main"/>
           <a:p xmlns:a="http://schemas.openxmlformats.org/drawingml/2006/main">
             <a:pPr algn="r">
+              <a:buNone/>
               <a:defRPr sz="750" b="1">
                 <a:solidFill>
                   <a:srgbClr val="617984"/>
@@ -7704,6 +7786,7 @@
           <a:lstStyle xmlns:a="http://schemas.openxmlformats.org/drawingml/2006/main"/>
           <a:p xmlns:a="http://schemas.openxmlformats.org/drawingml/2006/main">
             <a:pPr algn="l">
+              <a:buNone/>
               <a:defRPr sz="900" b="1">
                 <a:solidFill>
                   <a:srgbClr val="23D7E6"/>
@@ -7754,6 +7837,7 @@
           <a:lstStyle xmlns:a="http://schemas.openxmlformats.org/drawingml/2006/main"/>
           <a:p xmlns:a="http://schemas.openxmlformats.org/drawingml/2006/main">
             <a:pPr algn="l">
+              <a:buNone/>
               <a:defRPr sz="2700" b="1">
                 <a:solidFill>
                   <a:srgbClr val="EAFBFF"/>
@@ -7837,6 +7921,7 @@
           <a:lstStyle xmlns:a="http://schemas.openxmlformats.org/drawingml/2006/main"/>
           <a:p xmlns:a="http://schemas.openxmlformats.org/drawingml/2006/main">
             <a:pPr algn="l">
+              <a:buNone/>
               <a:defRPr sz="2100" b="1">
                 <a:solidFill>
                   <a:srgbClr val="23D7E6"/>
@@ -7887,6 +7972,7 @@
           <a:lstStyle xmlns:a="http://schemas.openxmlformats.org/drawingml/2006/main"/>
           <a:p xmlns:a="http://schemas.openxmlformats.org/drawingml/2006/main">
             <a:pPr algn="l">
+              <a:buNone/>
               <a:defRPr sz="1200" b="1">
                 <a:solidFill>
                   <a:srgbClr val="617984"/>
@@ -7937,6 +8023,7 @@
           <a:lstStyle xmlns:a="http://schemas.openxmlformats.org/drawingml/2006/main"/>
           <a:p xmlns:a="http://schemas.openxmlformats.org/drawingml/2006/main">
             <a:pPr algn="l">
+              <a:buNone/>
               <a:defRPr sz="2250" b="1">
                 <a:solidFill>
                   <a:srgbClr val="EAFBFF"/>
@@ -7987,6 +8074,7 @@
           <a:lstStyle xmlns:a="http://schemas.openxmlformats.org/drawingml/2006/main"/>
           <a:p xmlns:a="http://schemas.openxmlformats.org/drawingml/2006/main">
             <a:pPr algn="l">
+              <a:buNone/>
               <a:defRPr sz="1200" b="1">
                 <a:solidFill>
                   <a:srgbClr val="617984"/>
@@ -8037,6 +8125,7 @@
           <a:lstStyle xmlns:a="http://schemas.openxmlformats.org/drawingml/2006/main"/>
           <a:p xmlns:a="http://schemas.openxmlformats.org/drawingml/2006/main">
             <a:pPr algn="l">
+              <a:buNone/>
               <a:defRPr sz="2250" b="1">
                 <a:solidFill>
                   <a:srgbClr val="EAFBFF"/>
@@ -8087,6 +8176,7 @@
           <a:lstStyle xmlns:a="http://schemas.openxmlformats.org/drawingml/2006/main"/>
           <a:p xmlns:a="http://schemas.openxmlformats.org/drawingml/2006/main">
             <a:pPr algn="l">
+              <a:buNone/>
               <a:defRPr sz="1200" b="1">
                 <a:solidFill>
                   <a:srgbClr val="617984"/>
@@ -8137,6 +8227,7 @@
           <a:lstStyle xmlns:a="http://schemas.openxmlformats.org/drawingml/2006/main"/>
           <a:p xmlns:a="http://schemas.openxmlformats.org/drawingml/2006/main">
             <a:pPr algn="l">
+              <a:buNone/>
               <a:defRPr sz="2250" b="1">
                 <a:solidFill>
                   <a:srgbClr val="F8B84E"/>
@@ -8222,6 +8313,7 @@
           <a:lstStyle xmlns:a="http://schemas.openxmlformats.org/drawingml/2006/main"/>
           <a:p xmlns:a="http://schemas.openxmlformats.org/drawingml/2006/main">
             <a:pPr algn="l">
+              <a:buNone/>
               <a:defRPr sz="1350" b="1">
                 <a:solidFill>
                   <a:srgbClr val="EAFBFF"/>
@@ -8272,6 +8364,7 @@
           <a:lstStyle xmlns:a="http://schemas.openxmlformats.org/drawingml/2006/main"/>
           <a:p xmlns:a="http://schemas.openxmlformats.org/drawingml/2006/main">
             <a:pPr algn="l">
+              <a:buNone/>
               <a:defRPr sz="1050" b="0">
                 <a:solidFill>
                   <a:srgbClr val="9DB7C2"/>
@@ -8357,6 +8450,7 @@
           <a:lstStyle xmlns:a="http://schemas.openxmlformats.org/drawingml/2006/main"/>
           <a:p xmlns:a="http://schemas.openxmlformats.org/drawingml/2006/main">
             <a:pPr algn="l">
+              <a:buNone/>
               <a:defRPr sz="1350" b="1">
                 <a:solidFill>
                   <a:srgbClr val="EAFBFF"/>
@@ -8407,6 +8501,7 @@
           <a:lstStyle xmlns:a="http://schemas.openxmlformats.org/drawingml/2006/main"/>
           <a:p xmlns:a="http://schemas.openxmlformats.org/drawingml/2006/main">
             <a:pPr algn="l">
+              <a:buNone/>
               <a:defRPr sz="1050" b="0">
                 <a:solidFill>
                   <a:srgbClr val="9DB7C2"/>
@@ -8492,6 +8587,7 @@
           <a:lstStyle xmlns:a="http://schemas.openxmlformats.org/drawingml/2006/main"/>
           <a:p xmlns:a="http://schemas.openxmlformats.org/drawingml/2006/main">
             <a:pPr algn="l">
+              <a:buNone/>
               <a:defRPr sz="1350" b="1">
                 <a:solidFill>
                   <a:srgbClr val="EAFBFF"/>
@@ -8542,6 +8638,7 @@
           <a:lstStyle xmlns:a="http://schemas.openxmlformats.org/drawingml/2006/main"/>
           <a:p xmlns:a="http://schemas.openxmlformats.org/drawingml/2006/main">
             <a:pPr algn="l">
+              <a:buNone/>
               <a:defRPr sz="1050" b="0">
                 <a:solidFill>
                   <a:srgbClr val="9DB7C2"/>
@@ -8592,6 +8689,7 @@
           <a:lstStyle xmlns:a="http://schemas.openxmlformats.org/drawingml/2006/main"/>
           <a:p xmlns:a="http://schemas.openxmlformats.org/drawingml/2006/main">
             <a:pPr algn="l">
+              <a:buNone/>
               <a:defRPr sz="750" b="1">
                 <a:solidFill>
                   <a:srgbClr val="617984"/>
@@ -8642,6 +8740,7 @@
           <a:lstStyle xmlns:a="http://schemas.openxmlformats.org/drawingml/2006/main"/>
           <a:p xmlns:a="http://schemas.openxmlformats.org/drawingml/2006/main">
             <a:pPr algn="r">
+              <a:buNone/>
               <a:defRPr sz="750" b="1">
                 <a:solidFill>
                   <a:srgbClr val="617984"/>
@@ -8721,6 +8820,7 @@
           <a:lstStyle xmlns:a="http://schemas.openxmlformats.org/drawingml/2006/main"/>
           <a:p xmlns:a="http://schemas.openxmlformats.org/drawingml/2006/main">
             <a:pPr algn="l">
+              <a:buNone/>
               <a:defRPr sz="900" b="1">
                 <a:solidFill>
                   <a:srgbClr val="23D7E6"/>
@@ -8771,6 +8871,7 @@
           <a:lstStyle xmlns:a="http://schemas.openxmlformats.org/drawingml/2006/main"/>
           <a:p xmlns:a="http://schemas.openxmlformats.org/drawingml/2006/main">
             <a:pPr algn="l">
+              <a:buNone/>
               <a:defRPr sz="2700" b="1">
                 <a:solidFill>
                   <a:srgbClr val="EAFBFF"/>
@@ -8854,6 +8955,7 @@
           <a:lstStyle xmlns:a="http://schemas.openxmlformats.org/drawingml/2006/main"/>
           <a:p xmlns:a="http://schemas.openxmlformats.org/drawingml/2006/main">
             <a:pPr algn="ctr">
+              <a:buNone/>
               <a:defRPr sz="4350" b="1">
                 <a:solidFill>
                   <a:srgbClr val="23D7E6"/>
@@ -8904,6 +9006,7 @@
           <a:lstStyle xmlns:a="http://schemas.openxmlformats.org/drawingml/2006/main"/>
           <a:p xmlns:a="http://schemas.openxmlformats.org/drawingml/2006/main">
             <a:pPr algn="ctr">
+              <a:buNone/>
               <a:defRPr sz="1350" b="1">
                 <a:solidFill>
                   <a:srgbClr val="EAFBFF"/>
@@ -8987,6 +9090,7 @@
           <a:lstStyle xmlns:a="http://schemas.openxmlformats.org/drawingml/2006/main"/>
           <a:p xmlns:a="http://schemas.openxmlformats.org/drawingml/2006/main">
             <a:pPr algn="ctr">
+              <a:buNone/>
               <a:defRPr sz="4350" b="1">
                 <a:solidFill>
                   <a:srgbClr val="3A8DFF"/>
@@ -8999,7 +9103,7 @@
                   <a:srgbClr val="3A8DFF"/>
                 </a:solidFill>
               </a:rPr>
-              <a:t>11</a:t>
+              <a:t>12</a:t>
             </a:r>
           </a:p>
         </p:txBody>
@@ -9037,6 +9141,7 @@
           <a:lstStyle xmlns:a="http://schemas.openxmlformats.org/drawingml/2006/main"/>
           <a:p xmlns:a="http://schemas.openxmlformats.org/drawingml/2006/main">
             <a:pPr algn="ctr">
+              <a:buNone/>
               <a:defRPr sz="1350" b="1">
                 <a:solidFill>
                   <a:srgbClr val="EAFBFF"/>
@@ -9120,6 +9225,7 @@
           <a:lstStyle xmlns:a="http://schemas.openxmlformats.org/drawingml/2006/main"/>
           <a:p xmlns:a="http://schemas.openxmlformats.org/drawingml/2006/main">
             <a:pPr algn="ctr">
+              <a:buNone/>
               <a:defRPr sz="4350" b="1">
                 <a:solidFill>
                   <a:srgbClr val="1AAE9F"/>
@@ -9170,6 +9276,7 @@
           <a:lstStyle xmlns:a="http://schemas.openxmlformats.org/drawingml/2006/main"/>
           <a:p xmlns:a="http://schemas.openxmlformats.org/drawingml/2006/main">
             <a:pPr algn="ctr">
+              <a:buNone/>
               <a:defRPr sz="1350" b="1">
                 <a:solidFill>
                   <a:srgbClr val="EAFBFF"/>
@@ -9253,6 +9360,7 @@
           <a:lstStyle xmlns:a="http://schemas.openxmlformats.org/drawingml/2006/main"/>
           <a:p xmlns:a="http://schemas.openxmlformats.org/drawingml/2006/main">
             <a:pPr algn="ctr">
+              <a:buNone/>
               <a:defRPr sz="4350" b="1">
                 <a:solidFill>
                   <a:srgbClr val="F8B84E"/>
@@ -9303,6 +9411,7 @@
           <a:lstStyle xmlns:a="http://schemas.openxmlformats.org/drawingml/2006/main"/>
           <a:p xmlns:a="http://schemas.openxmlformats.org/drawingml/2006/main">
             <a:pPr algn="ctr">
+              <a:buNone/>
               <a:defRPr sz="1350" b="1">
                 <a:solidFill>
                   <a:srgbClr val="EAFBFF"/>
@@ -9386,6 +9495,7 @@
           <a:lstStyle xmlns:a="http://schemas.openxmlformats.org/drawingml/2006/main"/>
           <a:p xmlns:a="http://schemas.openxmlformats.org/drawingml/2006/main">
             <a:pPr algn="l">
+              <a:buNone/>
               <a:defRPr sz="1350" b="1">
                 <a:solidFill>
                   <a:srgbClr val="23D7E6"/>
@@ -9436,6 +9546,7 @@
           <a:lstStyle xmlns:a="http://schemas.openxmlformats.org/drawingml/2006/main"/>
           <a:p xmlns:a="http://schemas.openxmlformats.org/drawingml/2006/main">
             <a:pPr algn="l">
+              <a:buNone/>
               <a:defRPr sz="2025" b="1">
                 <a:solidFill>
                   <a:srgbClr val="EAFBFF"/>
@@ -9486,6 +9597,7 @@
           <a:lstStyle xmlns:a="http://schemas.openxmlformats.org/drawingml/2006/main"/>
           <a:p xmlns:a="http://schemas.openxmlformats.org/drawingml/2006/main">
             <a:pPr algn="l">
+              <a:buNone/>
               <a:defRPr sz="1725" b="0">
                 <a:solidFill>
                   <a:srgbClr val="9DB7C2"/>
@@ -9536,6 +9648,7 @@
           <a:lstStyle xmlns:a="http://schemas.openxmlformats.org/drawingml/2006/main"/>
           <a:p xmlns:a="http://schemas.openxmlformats.org/drawingml/2006/main">
             <a:pPr algn="l">
+              <a:buNone/>
               <a:defRPr sz="1275" b="1">
                 <a:solidFill>
                   <a:srgbClr val="F8B84E"/>
@@ -9586,6 +9699,7 @@
           <a:lstStyle xmlns:a="http://schemas.openxmlformats.org/drawingml/2006/main"/>
           <a:p xmlns:a="http://schemas.openxmlformats.org/drawingml/2006/main">
             <a:pPr algn="l">
+              <a:buNone/>
               <a:defRPr sz="750" b="1">
                 <a:solidFill>
                   <a:srgbClr val="617984"/>
@@ -9636,6 +9750,7 @@
           <a:lstStyle xmlns:a="http://schemas.openxmlformats.org/drawingml/2006/main"/>
           <a:p xmlns:a="http://schemas.openxmlformats.org/drawingml/2006/main">
             <a:pPr algn="r">
+              <a:buNone/>
               <a:defRPr sz="750" b="1">
                 <a:solidFill>
                   <a:srgbClr val="617984"/>
@@ -9715,6 +9830,7 @@
           <a:lstStyle xmlns:a="http://schemas.openxmlformats.org/drawingml/2006/main"/>
           <a:p xmlns:a="http://schemas.openxmlformats.org/drawingml/2006/main">
             <a:pPr algn="l">
+              <a:buNone/>
               <a:defRPr sz="900" b="1">
                 <a:solidFill>
                   <a:srgbClr val="23D7E6"/>
@@ -9765,6 +9881,7 @@
           <a:lstStyle xmlns:a="http://schemas.openxmlformats.org/drawingml/2006/main"/>
           <a:p xmlns:a="http://schemas.openxmlformats.org/drawingml/2006/main">
             <a:pPr algn="l">
+              <a:buNone/>
               <a:defRPr sz="2700" b="1">
                 <a:solidFill>
                   <a:srgbClr val="EAFBFF"/>
@@ -10015,6 +10132,7 @@
           <a:lstStyle xmlns:a="http://schemas.openxmlformats.org/drawingml/2006/main"/>
           <a:p xmlns:a="http://schemas.openxmlformats.org/drawingml/2006/main">
             <a:pPr algn="ctr">
+              <a:buNone/>
               <a:defRPr sz="1725" b="1">
                 <a:solidFill>
                   <a:srgbClr val="9CE68A"/>
@@ -10065,6 +10183,7 @@
           <a:lstStyle xmlns:a="http://schemas.openxmlformats.org/drawingml/2006/main"/>
           <a:p xmlns:a="http://schemas.openxmlformats.org/drawingml/2006/main">
             <a:pPr algn="ctr">
+              <a:buNone/>
               <a:defRPr sz="1125" b="1">
                 <a:solidFill>
                   <a:srgbClr val="EAFBFF"/>
@@ -10115,6 +10234,7 @@
           <a:lstStyle xmlns:a="http://schemas.openxmlformats.org/drawingml/2006/main"/>
           <a:p xmlns:a="http://schemas.openxmlformats.org/drawingml/2006/main">
             <a:pPr algn="ctr">
+              <a:buNone/>
               <a:defRPr sz="975" b="0">
                 <a:solidFill>
                   <a:srgbClr val="9DB7C2"/>
@@ -10200,6 +10320,7 @@
           <a:lstStyle xmlns:a="http://schemas.openxmlformats.org/drawingml/2006/main"/>
           <a:p xmlns:a="http://schemas.openxmlformats.org/drawingml/2006/main">
             <a:pPr algn="ctr">
+              <a:buNone/>
               <a:defRPr sz="1725" b="1">
                 <a:solidFill>
                   <a:srgbClr val="1AAE9F"/>
@@ -10250,6 +10371,7 @@
           <a:lstStyle xmlns:a="http://schemas.openxmlformats.org/drawingml/2006/main"/>
           <a:p xmlns:a="http://schemas.openxmlformats.org/drawingml/2006/main">
             <a:pPr algn="ctr">
+              <a:buNone/>
               <a:defRPr sz="1125" b="1">
                 <a:solidFill>
                   <a:srgbClr val="EAFBFF"/>
@@ -10300,6 +10422,7 @@
           <a:lstStyle xmlns:a="http://schemas.openxmlformats.org/drawingml/2006/main"/>
           <a:p xmlns:a="http://schemas.openxmlformats.org/drawingml/2006/main">
             <a:pPr algn="ctr">
+              <a:buNone/>
               <a:defRPr sz="975" b="0">
                 <a:solidFill>
                   <a:srgbClr val="9DB7C2"/>
@@ -10385,6 +10508,7 @@
           <a:lstStyle xmlns:a="http://schemas.openxmlformats.org/drawingml/2006/main"/>
           <a:p xmlns:a="http://schemas.openxmlformats.org/drawingml/2006/main">
             <a:pPr algn="ctr">
+              <a:buNone/>
               <a:defRPr sz="1725" b="1">
                 <a:solidFill>
                   <a:srgbClr val="F8B84E"/>
@@ -10435,6 +10559,7 @@
           <a:lstStyle xmlns:a="http://schemas.openxmlformats.org/drawingml/2006/main"/>
           <a:p xmlns:a="http://schemas.openxmlformats.org/drawingml/2006/main">
             <a:pPr algn="ctr">
+              <a:buNone/>
               <a:defRPr sz="1125" b="1">
                 <a:solidFill>
                   <a:srgbClr val="EAFBFF"/>
@@ -10485,6 +10610,7 @@
           <a:lstStyle xmlns:a="http://schemas.openxmlformats.org/drawingml/2006/main"/>
           <a:p xmlns:a="http://schemas.openxmlformats.org/drawingml/2006/main">
             <a:pPr algn="ctr">
+              <a:buNone/>
               <a:defRPr sz="975" b="0">
                 <a:solidFill>
                   <a:srgbClr val="9DB7C2"/>
@@ -10570,6 +10696,7 @@
           <a:lstStyle xmlns:a="http://schemas.openxmlformats.org/drawingml/2006/main"/>
           <a:p xmlns:a="http://schemas.openxmlformats.org/drawingml/2006/main">
             <a:pPr algn="ctr">
+              <a:buNone/>
               <a:defRPr sz="1725" b="1">
                 <a:solidFill>
                   <a:srgbClr val="3A8DFF"/>
@@ -10620,6 +10747,7 @@
           <a:lstStyle xmlns:a="http://schemas.openxmlformats.org/drawingml/2006/main"/>
           <a:p xmlns:a="http://schemas.openxmlformats.org/drawingml/2006/main">
             <a:pPr algn="ctr">
+              <a:buNone/>
               <a:defRPr sz="1125" b="1">
                 <a:solidFill>
                   <a:srgbClr val="EAFBFF"/>
@@ -10670,6 +10798,7 @@
           <a:lstStyle xmlns:a="http://schemas.openxmlformats.org/drawingml/2006/main"/>
           <a:p xmlns:a="http://schemas.openxmlformats.org/drawingml/2006/main">
             <a:pPr algn="ctr">
+              <a:buNone/>
               <a:defRPr sz="975" b="0">
                 <a:solidFill>
                   <a:srgbClr val="9DB7C2"/>
@@ -10755,6 +10884,7 @@
           <a:lstStyle xmlns:a="http://schemas.openxmlformats.org/drawingml/2006/main"/>
           <a:p xmlns:a="http://schemas.openxmlformats.org/drawingml/2006/main">
             <a:pPr algn="ctr">
+              <a:buNone/>
               <a:defRPr sz="1725" b="1">
                 <a:solidFill>
                   <a:srgbClr val="23D7E6"/>
@@ -10805,6 +10935,7 @@
           <a:lstStyle xmlns:a="http://schemas.openxmlformats.org/drawingml/2006/main"/>
           <a:p xmlns:a="http://schemas.openxmlformats.org/drawingml/2006/main">
             <a:pPr algn="ctr">
+              <a:buNone/>
               <a:defRPr sz="1125" b="1">
                 <a:solidFill>
                   <a:srgbClr val="EAFBFF"/>
@@ -10855,6 +10986,7 @@
           <a:lstStyle xmlns:a="http://schemas.openxmlformats.org/drawingml/2006/main"/>
           <a:p xmlns:a="http://schemas.openxmlformats.org/drawingml/2006/main">
             <a:pPr algn="ctr">
+              <a:buNone/>
               <a:defRPr sz="975" b="0">
                 <a:solidFill>
                   <a:srgbClr val="9DB7C2"/>
@@ -10905,6 +11037,7 @@
           <a:lstStyle xmlns:a="http://schemas.openxmlformats.org/drawingml/2006/main"/>
           <a:p xmlns:a="http://schemas.openxmlformats.org/drawingml/2006/main">
             <a:pPr algn="ctr">
+              <a:buNone/>
               <a:defRPr sz="2250" b="1">
                 <a:solidFill>
                   <a:srgbClr val="EAFBFF"/>
@@ -10955,6 +11088,7 @@
           <a:lstStyle xmlns:a="http://schemas.openxmlformats.org/drawingml/2006/main"/>
           <a:p xmlns:a="http://schemas.openxmlformats.org/drawingml/2006/main">
             <a:pPr algn="ctr">
+              <a:buNone/>
               <a:defRPr sz="1350" b="0">
                 <a:solidFill>
                   <a:srgbClr val="9DB7C2"/>
@@ -11005,6 +11139,7 @@
           <a:lstStyle xmlns:a="http://schemas.openxmlformats.org/drawingml/2006/main"/>
           <a:p xmlns:a="http://schemas.openxmlformats.org/drawingml/2006/main">
             <a:pPr algn="ctr">
+              <a:buNone/>
               <a:defRPr sz="1425" b="1">
                 <a:solidFill>
                   <a:srgbClr val="F8B84E"/>
@@ -11055,6 +11190,7 @@
           <a:lstStyle xmlns:a="http://schemas.openxmlformats.org/drawingml/2006/main"/>
           <a:p xmlns:a="http://schemas.openxmlformats.org/drawingml/2006/main">
             <a:pPr algn="l">
+              <a:buNone/>
               <a:defRPr sz="750" b="1">
                 <a:solidFill>
                   <a:srgbClr val="617984"/>
@@ -11105,6 +11241,7 @@
           <a:lstStyle xmlns:a="http://schemas.openxmlformats.org/drawingml/2006/main"/>
           <a:p xmlns:a="http://schemas.openxmlformats.org/drawingml/2006/main">
             <a:pPr algn="r">
+              <a:buNone/>
               <a:defRPr sz="750" b="1">
                 <a:solidFill>
                   <a:srgbClr val="617984"/>
@@ -11184,6 +11321,7 @@
           <a:lstStyle xmlns:a="http://schemas.openxmlformats.org/drawingml/2006/main"/>
           <a:p xmlns:a="http://schemas.openxmlformats.org/drawingml/2006/main">
             <a:pPr algn="l">
+              <a:buNone/>
               <a:defRPr sz="900" b="1">
                 <a:solidFill>
                   <a:srgbClr val="23D7E6"/>
@@ -11234,6 +11372,7 @@
           <a:lstStyle xmlns:a="http://schemas.openxmlformats.org/drawingml/2006/main"/>
           <a:p xmlns:a="http://schemas.openxmlformats.org/drawingml/2006/main">
             <a:pPr algn="l">
+              <a:buNone/>
               <a:defRPr sz="2700" b="1">
                 <a:solidFill>
                   <a:srgbClr val="EAFBFF"/>
@@ -11649,6 +11788,7 @@
           <a:lstStyle xmlns:a="http://schemas.openxmlformats.org/drawingml/2006/main"/>
           <a:p xmlns:a="http://schemas.openxmlformats.org/drawingml/2006/main">
             <a:pPr algn="l">
+              <a:buNone/>
               <a:defRPr sz="1350" b="1">
                 <a:solidFill>
                   <a:srgbClr val="EAFBFF"/>
@@ -11699,6 +11839,7 @@
           <a:lstStyle xmlns:a="http://schemas.openxmlformats.org/drawingml/2006/main"/>
           <a:p xmlns:a="http://schemas.openxmlformats.org/drawingml/2006/main">
             <a:pPr algn="l">
+              <a:buNone/>
               <a:defRPr sz="1050" b="0">
                 <a:solidFill>
                   <a:srgbClr val="9DB7C2"/>
@@ -11784,6 +11925,7 @@
           <a:lstStyle xmlns:a="http://schemas.openxmlformats.org/drawingml/2006/main"/>
           <a:p xmlns:a="http://schemas.openxmlformats.org/drawingml/2006/main">
             <a:pPr algn="l">
+              <a:buNone/>
               <a:defRPr sz="1350" b="1">
                 <a:solidFill>
                   <a:srgbClr val="EAFBFF"/>
@@ -11834,6 +11976,7 @@
           <a:lstStyle xmlns:a="http://schemas.openxmlformats.org/drawingml/2006/main"/>
           <a:p xmlns:a="http://schemas.openxmlformats.org/drawingml/2006/main">
             <a:pPr algn="l">
+              <a:buNone/>
               <a:defRPr sz="1050" b="0">
                 <a:solidFill>
                   <a:srgbClr val="9DB7C2"/>
@@ -11919,6 +12062,7 @@
           <a:lstStyle xmlns:a="http://schemas.openxmlformats.org/drawingml/2006/main"/>
           <a:p xmlns:a="http://schemas.openxmlformats.org/drawingml/2006/main">
             <a:pPr algn="l">
+              <a:buNone/>
               <a:defRPr sz="1350" b="1">
                 <a:solidFill>
                   <a:srgbClr val="EAFBFF"/>
@@ -11969,6 +12113,7 @@
           <a:lstStyle xmlns:a="http://schemas.openxmlformats.org/drawingml/2006/main"/>
           <a:p xmlns:a="http://schemas.openxmlformats.org/drawingml/2006/main">
             <a:pPr algn="l">
+              <a:buNone/>
               <a:defRPr sz="1050" b="0">
                 <a:solidFill>
                   <a:srgbClr val="9DB7C2"/>
@@ -12054,6 +12199,7 @@
           <a:lstStyle xmlns:a="http://schemas.openxmlformats.org/drawingml/2006/main"/>
           <a:p xmlns:a="http://schemas.openxmlformats.org/drawingml/2006/main">
             <a:pPr algn="l">
+              <a:buNone/>
               <a:defRPr sz="1350" b="1">
                 <a:solidFill>
                   <a:srgbClr val="EAFBFF"/>
@@ -12104,6 +12250,7 @@
           <a:lstStyle xmlns:a="http://schemas.openxmlformats.org/drawingml/2006/main"/>
           <a:p xmlns:a="http://schemas.openxmlformats.org/drawingml/2006/main">
             <a:pPr algn="l">
+              <a:buNone/>
               <a:defRPr sz="1050" b="0">
                 <a:solidFill>
                   <a:srgbClr val="9DB7C2"/>
@@ -12189,6 +12336,7 @@
           <a:lstStyle xmlns:a="http://schemas.openxmlformats.org/drawingml/2006/main"/>
           <a:p xmlns:a="http://schemas.openxmlformats.org/drawingml/2006/main">
             <a:pPr algn="l">
+              <a:buNone/>
               <a:defRPr sz="1350" b="1">
                 <a:solidFill>
                   <a:srgbClr val="EAFBFF"/>
@@ -12239,6 +12387,7 @@
           <a:lstStyle xmlns:a="http://schemas.openxmlformats.org/drawingml/2006/main"/>
           <a:p xmlns:a="http://schemas.openxmlformats.org/drawingml/2006/main">
             <a:pPr algn="l">
+              <a:buNone/>
               <a:defRPr sz="1050" b="0">
                 <a:solidFill>
                   <a:srgbClr val="9DB7C2"/>
@@ -12324,6 +12473,7 @@
           <a:lstStyle xmlns:a="http://schemas.openxmlformats.org/drawingml/2006/main"/>
           <a:p xmlns:a="http://schemas.openxmlformats.org/drawingml/2006/main">
             <a:pPr algn="l">
+              <a:buNone/>
               <a:defRPr sz="1350" b="1">
                 <a:solidFill>
                   <a:srgbClr val="EAFBFF"/>
@@ -12374,6 +12524,7 @@
           <a:lstStyle xmlns:a="http://schemas.openxmlformats.org/drawingml/2006/main"/>
           <a:p xmlns:a="http://schemas.openxmlformats.org/drawingml/2006/main">
             <a:pPr algn="l">
+              <a:buNone/>
               <a:defRPr sz="1050" b="0">
                 <a:solidFill>
                   <a:srgbClr val="9DB7C2"/>
@@ -12459,6 +12610,7 @@
           <a:lstStyle xmlns:a="http://schemas.openxmlformats.org/drawingml/2006/main"/>
           <a:p xmlns:a="http://schemas.openxmlformats.org/drawingml/2006/main">
             <a:pPr algn="l">
+              <a:buNone/>
               <a:defRPr sz="1350" b="1">
                 <a:solidFill>
                   <a:srgbClr val="EAFBFF"/>
@@ -12509,6 +12661,7 @@
           <a:lstStyle xmlns:a="http://schemas.openxmlformats.org/drawingml/2006/main"/>
           <a:p xmlns:a="http://schemas.openxmlformats.org/drawingml/2006/main">
             <a:pPr algn="l">
+              <a:buNone/>
               <a:defRPr sz="1050" b="0">
                 <a:solidFill>
                   <a:srgbClr val="9DB7C2"/>
@@ -12594,6 +12747,7 @@
           <a:lstStyle xmlns:a="http://schemas.openxmlformats.org/drawingml/2006/main"/>
           <a:p xmlns:a="http://schemas.openxmlformats.org/drawingml/2006/main">
             <a:pPr algn="l">
+              <a:buNone/>
               <a:defRPr sz="1350" b="1">
                 <a:solidFill>
                   <a:srgbClr val="EAFBFF"/>
@@ -12644,6 +12798,7 @@
           <a:lstStyle xmlns:a="http://schemas.openxmlformats.org/drawingml/2006/main"/>
           <a:p xmlns:a="http://schemas.openxmlformats.org/drawingml/2006/main">
             <a:pPr algn="l">
+              <a:buNone/>
               <a:defRPr sz="1050" b="0">
                 <a:solidFill>
                   <a:srgbClr val="9DB7C2"/>
@@ -12729,6 +12884,7 @@
           <a:lstStyle xmlns:a="http://schemas.openxmlformats.org/drawingml/2006/main"/>
           <a:p xmlns:a="http://schemas.openxmlformats.org/drawingml/2006/main">
             <a:pPr algn="l">
+              <a:buNone/>
               <a:defRPr sz="1350" b="1">
                 <a:solidFill>
                   <a:srgbClr val="EAFBFF"/>
@@ -12779,6 +12935,7 @@
           <a:lstStyle xmlns:a="http://schemas.openxmlformats.org/drawingml/2006/main"/>
           <a:p xmlns:a="http://schemas.openxmlformats.org/drawingml/2006/main">
             <a:pPr algn="l">
+              <a:buNone/>
               <a:defRPr sz="1050" b="0">
                 <a:solidFill>
                   <a:srgbClr val="9DB7C2"/>
@@ -12864,6 +13021,7 @@
           <a:lstStyle xmlns:a="http://schemas.openxmlformats.org/drawingml/2006/main"/>
           <a:p xmlns:a="http://schemas.openxmlformats.org/drawingml/2006/main">
             <a:pPr algn="l">
+              <a:buNone/>
               <a:defRPr sz="1350" b="1">
                 <a:solidFill>
                   <a:srgbClr val="EAFBFF"/>
@@ -12914,6 +13072,7 @@
           <a:lstStyle xmlns:a="http://schemas.openxmlformats.org/drawingml/2006/main"/>
           <a:p xmlns:a="http://schemas.openxmlformats.org/drawingml/2006/main">
             <a:pPr algn="l">
+              <a:buNone/>
               <a:defRPr sz="1050" b="0">
                 <a:solidFill>
                   <a:srgbClr val="9DB7C2"/>
@@ -12964,6 +13123,7 @@
           <a:lstStyle xmlns:a="http://schemas.openxmlformats.org/drawingml/2006/main"/>
           <a:p xmlns:a="http://schemas.openxmlformats.org/drawingml/2006/main">
             <a:pPr algn="ctr">
+              <a:buNone/>
               <a:defRPr sz="2175" b="1">
                 <a:solidFill>
                   <a:srgbClr val="EAFBFF"/>
@@ -13014,6 +13174,7 @@
           <a:lstStyle xmlns:a="http://schemas.openxmlformats.org/drawingml/2006/main"/>
           <a:p xmlns:a="http://schemas.openxmlformats.org/drawingml/2006/main">
             <a:pPr algn="l">
+              <a:buNone/>
               <a:defRPr sz="750" b="1">
                 <a:solidFill>
                   <a:srgbClr val="617984"/>
@@ -13064,6 +13225,7 @@
           <a:lstStyle xmlns:a="http://schemas.openxmlformats.org/drawingml/2006/main"/>
           <a:p xmlns:a="http://schemas.openxmlformats.org/drawingml/2006/main">
             <a:pPr algn="r">
+              <a:buNone/>
               <a:defRPr sz="750" b="1">
                 <a:solidFill>
                   <a:srgbClr val="617984"/>
@@ -13143,6 +13305,7 @@
           <a:lstStyle xmlns:a="http://schemas.openxmlformats.org/drawingml/2006/main"/>
           <a:p xmlns:a="http://schemas.openxmlformats.org/drawingml/2006/main">
             <a:pPr algn="l">
+              <a:buNone/>
               <a:defRPr sz="900" b="1">
                 <a:solidFill>
                   <a:srgbClr val="23D7E6"/>
@@ -13193,6 +13356,7 @@
           <a:lstStyle xmlns:a="http://schemas.openxmlformats.org/drawingml/2006/main"/>
           <a:p xmlns:a="http://schemas.openxmlformats.org/drawingml/2006/main">
             <a:pPr algn="l">
+              <a:buNone/>
               <a:defRPr sz="2700" b="1">
                 <a:solidFill>
                   <a:srgbClr val="EAFBFF"/>
@@ -13377,6 +13541,7 @@
           <a:lstStyle xmlns:a="http://schemas.openxmlformats.org/drawingml/2006/main"/>
           <a:p xmlns:a="http://schemas.openxmlformats.org/drawingml/2006/main">
             <a:pPr algn="l">
+              <a:buNone/>
               <a:defRPr sz="1350" b="1">
                 <a:solidFill>
                   <a:srgbClr val="EAFBFF"/>
@@ -13427,6 +13592,7 @@
           <a:lstStyle xmlns:a="http://schemas.openxmlformats.org/drawingml/2006/main"/>
           <a:p xmlns:a="http://schemas.openxmlformats.org/drawingml/2006/main">
             <a:pPr algn="l">
+              <a:buNone/>
               <a:defRPr sz="1050" b="0">
                 <a:solidFill>
                   <a:srgbClr val="9DB7C2"/>
@@ -13444,6 +13610,7 @@
           </a:p>
           <a:p xmlns:a="http://schemas.openxmlformats.org/drawingml/2006/main">
             <a:pPr algn="l">
+              <a:buNone/>
               <a:defRPr sz="1050" b="0">
                 <a:solidFill>
                   <a:srgbClr val="9DB7C2"/>
@@ -13461,6 +13628,7 @@
           </a:p>
           <a:p xmlns:a="http://schemas.openxmlformats.org/drawingml/2006/main">
             <a:pPr algn="l">
+              <a:buNone/>
               <a:defRPr sz="1050" b="0">
                 <a:solidFill>
                   <a:srgbClr val="9DB7C2"/>
@@ -13483,6 +13651,7 @@
           </a:p>
           <a:p xmlns:a="http://schemas.openxmlformats.org/drawingml/2006/main">
             <a:pPr algn="l">
+              <a:buNone/>
               <a:defRPr sz="1050" b="0">
                 <a:solidFill>
                   <a:srgbClr val="9DB7C2"/>
@@ -13568,6 +13737,7 @@
           <a:lstStyle xmlns:a="http://schemas.openxmlformats.org/drawingml/2006/main"/>
           <a:p xmlns:a="http://schemas.openxmlformats.org/drawingml/2006/main">
             <a:pPr algn="l">
+              <a:buNone/>
               <a:defRPr sz="1350" b="1">
                 <a:solidFill>
                   <a:srgbClr val="EAFBFF"/>
@@ -13618,6 +13788,7 @@
           <a:lstStyle xmlns:a="http://schemas.openxmlformats.org/drawingml/2006/main"/>
           <a:p xmlns:a="http://schemas.openxmlformats.org/drawingml/2006/main">
             <a:pPr algn="l">
+              <a:buNone/>
               <a:defRPr sz="1050" b="0">
                 <a:solidFill>
                   <a:srgbClr val="9DB7C2"/>
@@ -13635,6 +13806,7 @@
           </a:p>
           <a:p xmlns:a="http://schemas.openxmlformats.org/drawingml/2006/main">
             <a:pPr algn="l">
+              <a:buNone/>
               <a:defRPr sz="1050" b="0">
                 <a:solidFill>
                   <a:srgbClr val="9DB7C2"/>
@@ -13652,6 +13824,7 @@
           </a:p>
           <a:p xmlns:a="http://schemas.openxmlformats.org/drawingml/2006/main">
             <a:pPr algn="l">
+              <a:buNone/>
               <a:defRPr sz="1050" b="0">
                 <a:solidFill>
                   <a:srgbClr val="9DB7C2"/>
@@ -13669,6 +13842,7 @@
           </a:p>
           <a:p xmlns:a="http://schemas.openxmlformats.org/drawingml/2006/main">
             <a:pPr algn="l">
+              <a:buNone/>
               <a:defRPr sz="1050" b="0">
                 <a:solidFill>
                   <a:srgbClr val="9DB7C2"/>
@@ -13754,6 +13928,7 @@
           <a:lstStyle xmlns:a="http://schemas.openxmlformats.org/drawingml/2006/main"/>
           <a:p xmlns:a="http://schemas.openxmlformats.org/drawingml/2006/main">
             <a:pPr algn="l">
+              <a:buNone/>
               <a:defRPr sz="1350" b="1">
                 <a:solidFill>
                   <a:srgbClr val="EAFBFF"/>
@@ -13804,6 +13979,7 @@
           <a:lstStyle xmlns:a="http://schemas.openxmlformats.org/drawingml/2006/main"/>
           <a:p xmlns:a="http://schemas.openxmlformats.org/drawingml/2006/main">
             <a:pPr algn="l">
+              <a:buNone/>
               <a:defRPr sz="1050" b="0">
                 <a:solidFill>
                   <a:srgbClr val="9DB7C2"/>
@@ -13826,6 +14002,7 @@
           </a:p>
           <a:p xmlns:a="http://schemas.openxmlformats.org/drawingml/2006/main">
             <a:pPr algn="l">
+              <a:buNone/>
               <a:defRPr sz="1050" b="0">
                 <a:solidFill>
                   <a:srgbClr val="9DB7C2"/>
@@ -13843,6 +14020,7 @@
           </a:p>
           <a:p xmlns:a="http://schemas.openxmlformats.org/drawingml/2006/main">
             <a:pPr algn="l">
+              <a:buNone/>
               <a:defRPr sz="1050" b="0">
                 <a:solidFill>
                   <a:srgbClr val="9DB7C2"/>
@@ -13928,6 +14106,7 @@
           <a:lstStyle xmlns:a="http://schemas.openxmlformats.org/drawingml/2006/main"/>
           <a:p xmlns:a="http://schemas.openxmlformats.org/drawingml/2006/main">
             <a:pPr algn="l">
+              <a:buNone/>
               <a:defRPr sz="1350" b="1">
                 <a:solidFill>
                   <a:srgbClr val="EAFBFF"/>
@@ -13978,6 +14157,7 @@
           <a:lstStyle xmlns:a="http://schemas.openxmlformats.org/drawingml/2006/main"/>
           <a:p xmlns:a="http://schemas.openxmlformats.org/drawingml/2006/main">
             <a:pPr algn="l">
+              <a:buNone/>
               <a:defRPr sz="1050" b="0">
                 <a:solidFill>
                   <a:srgbClr val="9DB7C2"/>
@@ -14063,6 +14243,7 @@
           <a:lstStyle xmlns:a="http://schemas.openxmlformats.org/drawingml/2006/main"/>
           <a:p xmlns:a="http://schemas.openxmlformats.org/drawingml/2006/main">
             <a:pPr algn="l">
+              <a:buNone/>
               <a:defRPr sz="1350" b="1">
                 <a:solidFill>
                   <a:srgbClr val="EAFBFF"/>
@@ -14113,6 +14294,7 @@
           <a:lstStyle xmlns:a="http://schemas.openxmlformats.org/drawingml/2006/main"/>
           <a:p xmlns:a="http://schemas.openxmlformats.org/drawingml/2006/main">
             <a:pPr algn="l">
+              <a:buNone/>
               <a:defRPr sz="1050" b="0">
                 <a:solidFill>
                   <a:srgbClr val="9DB7C2"/>
@@ -14163,6 +14345,7 @@
           <a:lstStyle xmlns:a="http://schemas.openxmlformats.org/drawingml/2006/main"/>
           <a:p xmlns:a="http://schemas.openxmlformats.org/drawingml/2006/main">
             <a:pPr algn="ctr">
+              <a:buNone/>
               <a:defRPr sz="1425" b="1">
                 <a:solidFill>
                   <a:srgbClr val="F8B84E"/>
@@ -14213,6 +14396,7 @@
           <a:lstStyle xmlns:a="http://schemas.openxmlformats.org/drawingml/2006/main"/>
           <a:p xmlns:a="http://schemas.openxmlformats.org/drawingml/2006/main">
             <a:pPr algn="l">
+              <a:buNone/>
               <a:defRPr sz="750" b="1">
                 <a:solidFill>
                   <a:srgbClr val="617984"/>
@@ -14263,6 +14447,7 @@
           <a:lstStyle xmlns:a="http://schemas.openxmlformats.org/drawingml/2006/main"/>
           <a:p xmlns:a="http://schemas.openxmlformats.org/drawingml/2006/main">
             <a:pPr algn="r">
+              <a:buNone/>
               <a:defRPr sz="750" b="1">
                 <a:solidFill>
                   <a:srgbClr val="617984"/>
@@ -14342,6 +14527,7 @@
           <a:lstStyle xmlns:a="http://schemas.openxmlformats.org/drawingml/2006/main"/>
           <a:p xmlns:a="http://schemas.openxmlformats.org/drawingml/2006/main">
             <a:pPr algn="l">
+              <a:buNone/>
               <a:defRPr sz="900" b="1">
                 <a:solidFill>
                   <a:srgbClr val="23D7E6"/>
@@ -14392,6 +14578,7 @@
           <a:lstStyle xmlns:a="http://schemas.openxmlformats.org/drawingml/2006/main"/>
           <a:p xmlns:a="http://schemas.openxmlformats.org/drawingml/2006/main">
             <a:pPr algn="l">
+              <a:buNone/>
               <a:defRPr sz="2700" b="1">
                 <a:solidFill>
                   <a:srgbClr val="EAFBFF"/>
@@ -14510,6 +14697,7 @@
           <a:lstStyle xmlns:a="http://schemas.openxmlformats.org/drawingml/2006/main"/>
           <a:p xmlns:a="http://schemas.openxmlformats.org/drawingml/2006/main">
             <a:pPr algn="l">
+              <a:buNone/>
               <a:defRPr sz="1350" b="1">
                 <a:solidFill>
                   <a:srgbClr val="FF756B"/>
@@ -14560,6 +14748,7 @@
           <a:lstStyle xmlns:a="http://schemas.openxmlformats.org/drawingml/2006/main"/>
           <a:p xmlns:a="http://schemas.openxmlformats.org/drawingml/2006/main">
             <a:pPr algn="l">
+              <a:buNone/>
               <a:defRPr sz="1350" b="1">
                 <a:solidFill>
                   <a:srgbClr val="EAFBFF"/>
@@ -14577,6 +14766,7 @@
           </a:p>
           <a:p xmlns:a="http://schemas.openxmlformats.org/drawingml/2006/main">
             <a:pPr algn="l">
+              <a:buNone/>
               <a:defRPr sz="1350" b="1">
                 <a:solidFill>
                   <a:srgbClr val="EAFBFF"/>
@@ -14594,6 +14784,7 @@
           </a:p>
           <a:p xmlns:a="http://schemas.openxmlformats.org/drawingml/2006/main">
             <a:pPr algn="l">
+              <a:buNone/>
               <a:defRPr sz="1350" b="1">
                 <a:solidFill>
                   <a:srgbClr val="EAFBFF"/>
@@ -14679,6 +14870,7 @@
           <a:lstStyle xmlns:a="http://schemas.openxmlformats.org/drawingml/2006/main"/>
           <a:p xmlns:a="http://schemas.openxmlformats.org/drawingml/2006/main">
             <a:pPr algn="l">
+              <a:buNone/>
               <a:defRPr sz="1350" b="1">
                 <a:solidFill>
                   <a:srgbClr val="23D7E6"/>
@@ -14729,6 +14921,7 @@
           <a:lstStyle xmlns:a="http://schemas.openxmlformats.org/drawingml/2006/main"/>
           <a:p xmlns:a="http://schemas.openxmlformats.org/drawingml/2006/main">
             <a:pPr algn="l">
+              <a:buNone/>
               <a:defRPr sz="1350" b="1">
                 <a:solidFill>
                   <a:srgbClr val="EAFBFF"/>
@@ -14746,6 +14939,7 @@
           </a:p>
           <a:p xmlns:a="http://schemas.openxmlformats.org/drawingml/2006/main">
             <a:pPr algn="l">
+              <a:buNone/>
               <a:defRPr sz="1350" b="1">
                 <a:solidFill>
                   <a:srgbClr val="EAFBFF"/>
@@ -14831,6 +15025,7 @@
           <a:lstStyle xmlns:a="http://schemas.openxmlformats.org/drawingml/2006/main"/>
           <a:p xmlns:a="http://schemas.openxmlformats.org/drawingml/2006/main">
             <a:pPr algn="l">
+              <a:buNone/>
               <a:defRPr sz="1350" b="1">
                 <a:solidFill>
                   <a:srgbClr val="1AAE9F"/>
@@ -14881,6 +15076,7 @@
           <a:lstStyle xmlns:a="http://schemas.openxmlformats.org/drawingml/2006/main"/>
           <a:p xmlns:a="http://schemas.openxmlformats.org/drawingml/2006/main">
             <a:pPr algn="l">
+              <a:buNone/>
               <a:defRPr sz="1350" b="1">
                 <a:solidFill>
                   <a:srgbClr val="EAFBFF"/>
@@ -14898,6 +15094,7 @@
           </a:p>
           <a:p xmlns:a="http://schemas.openxmlformats.org/drawingml/2006/main">
             <a:pPr algn="l">
+              <a:buNone/>
               <a:defRPr sz="1350" b="1">
                 <a:solidFill>
                   <a:srgbClr val="EAFBFF"/>
@@ -14983,6 +15180,7 @@
           <a:lstStyle xmlns:a="http://schemas.openxmlformats.org/drawingml/2006/main"/>
           <a:p xmlns:a="http://schemas.openxmlformats.org/drawingml/2006/main">
             <a:pPr algn="l">
+              <a:buNone/>
               <a:defRPr sz="1350" b="1">
                 <a:solidFill>
                   <a:srgbClr val="F8B84E"/>
@@ -15033,6 +15231,7 @@
           <a:lstStyle xmlns:a="http://schemas.openxmlformats.org/drawingml/2006/main"/>
           <a:p xmlns:a="http://schemas.openxmlformats.org/drawingml/2006/main">
             <a:pPr algn="l">
+              <a:buNone/>
               <a:defRPr sz="1350" b="1">
                 <a:solidFill>
                   <a:srgbClr val="EAFBFF"/>
@@ -15118,6 +15317,7 @@
           <a:lstStyle xmlns:a="http://schemas.openxmlformats.org/drawingml/2006/main"/>
           <a:p xmlns:a="http://schemas.openxmlformats.org/drawingml/2006/main">
             <a:pPr algn="l">
+              <a:buNone/>
               <a:defRPr sz="1350" b="1">
                 <a:solidFill>
                   <a:srgbClr val="9CE68A"/>
@@ -15168,6 +15368,7 @@
           <a:lstStyle xmlns:a="http://schemas.openxmlformats.org/drawingml/2006/main"/>
           <a:p xmlns:a="http://schemas.openxmlformats.org/drawingml/2006/main">
             <a:pPr algn="l">
+              <a:buNone/>
               <a:defRPr sz="1350" b="1">
                 <a:solidFill>
                   <a:srgbClr val="EAFBFF"/>
@@ -15218,6 +15419,7 @@
           <a:lstStyle xmlns:a="http://schemas.openxmlformats.org/drawingml/2006/main"/>
           <a:p xmlns:a="http://schemas.openxmlformats.org/drawingml/2006/main">
             <a:pPr algn="ctr">
+              <a:buNone/>
               <a:defRPr sz="1275" b="1">
                 <a:solidFill>
                   <a:srgbClr val="9DB7C2"/>
@@ -15268,6 +15470,7 @@
           <a:lstStyle xmlns:a="http://schemas.openxmlformats.org/drawingml/2006/main"/>
           <a:p xmlns:a="http://schemas.openxmlformats.org/drawingml/2006/main">
             <a:pPr algn="l">
+              <a:buNone/>
               <a:defRPr sz="750" b="1">
                 <a:solidFill>
                   <a:srgbClr val="617984"/>
@@ -15318,6 +15521,7 @@
           <a:lstStyle xmlns:a="http://schemas.openxmlformats.org/drawingml/2006/main"/>
           <a:p xmlns:a="http://schemas.openxmlformats.org/drawingml/2006/main">
             <a:pPr algn="r">
+              <a:buNone/>
               <a:defRPr sz="750" b="1">
                 <a:solidFill>
                   <a:srgbClr val="617984"/>
@@ -15397,6 +15601,7 @@
           <a:lstStyle xmlns:a="http://schemas.openxmlformats.org/drawingml/2006/main"/>
           <a:p xmlns:a="http://schemas.openxmlformats.org/drawingml/2006/main">
             <a:pPr algn="l">
+              <a:buNone/>
               <a:defRPr sz="900" b="1">
                 <a:solidFill>
                   <a:srgbClr val="23D7E6"/>
@@ -15447,6 +15652,7 @@
           <a:lstStyle xmlns:a="http://schemas.openxmlformats.org/drawingml/2006/main"/>
           <a:p xmlns:a="http://schemas.openxmlformats.org/drawingml/2006/main">
             <a:pPr algn="l">
+              <a:buNone/>
               <a:defRPr sz="2700" b="1">
                 <a:solidFill>
                   <a:srgbClr val="EAFBFF"/>
@@ -15530,6 +15736,7 @@
           <a:lstStyle xmlns:a="http://schemas.openxmlformats.org/drawingml/2006/main"/>
           <a:p xmlns:a="http://schemas.openxmlformats.org/drawingml/2006/main">
             <a:pPr algn="l">
+              <a:buNone/>
               <a:defRPr sz="4650" b="1">
                 <a:solidFill>
                   <a:srgbClr val="23D7E6"/>
@@ -15580,6 +15787,7 @@
           <a:lstStyle xmlns:a="http://schemas.openxmlformats.org/drawingml/2006/main"/>
           <a:p xmlns:a="http://schemas.openxmlformats.org/drawingml/2006/main">
             <a:pPr algn="l">
+              <a:buNone/>
               <a:defRPr sz="1350" b="1">
                 <a:solidFill>
                   <a:srgbClr val="EAFBFF"/>
@@ -15630,6 +15838,7 @@
           <a:lstStyle xmlns:a="http://schemas.openxmlformats.org/drawingml/2006/main"/>
           <a:p xmlns:a="http://schemas.openxmlformats.org/drawingml/2006/main">
             <a:pPr algn="l">
+              <a:buNone/>
               <a:defRPr sz="1350" b="1">
                 <a:solidFill>
                   <a:srgbClr val="F8B84E"/>
@@ -15680,6 +15889,7 @@
           <a:lstStyle xmlns:a="http://schemas.openxmlformats.org/drawingml/2006/main"/>
           <a:p xmlns:a="http://schemas.openxmlformats.org/drawingml/2006/main">
             <a:pPr algn="l">
+              <a:buNone/>
               <a:defRPr sz="1350" b="1">
                 <a:solidFill>
                   <a:srgbClr val="9DB7C2"/>
@@ -15730,6 +15940,7 @@
           <a:lstStyle xmlns:a="http://schemas.openxmlformats.org/drawingml/2006/main"/>
           <a:p xmlns:a="http://schemas.openxmlformats.org/drawingml/2006/main">
             <a:pPr algn="l">
+              <a:buNone/>
               <a:defRPr sz="2550" b="1">
                 <a:solidFill>
                   <a:srgbClr val="FF756B"/>
@@ -15749,7 +15960,7 @@
       </p:sp>
       <p:graphicFrame>
         <p:nvGraphicFramePr>
-          <p:cNvPr id="21" name="Chart"/>
+          <p:cNvPr id="23" name="Chart"/>
           <p:cNvGraphicFramePr/>
           <p:nvPr/>
         </p:nvGraphicFramePr>
@@ -15759,7 +15970,7 @@
         </p:xfrm>
         <a:graphic xmlns:a="http://schemas.openxmlformats.org/drawingml/2006/main">
           <a:graphicData uri="http://schemas.openxmlformats.org/drawingml/2006/chart">
-            <c:chart xmlns:r="http://schemas.openxmlformats.org/officeDocument/2006/relationships" xmlns:c="http://schemas.openxmlformats.org/drawingml/2006/chart" r:id="R577ad11248bc4b20"/>
+            <c:chart xmlns:r="http://schemas.openxmlformats.org/officeDocument/2006/relationships" xmlns:c="http://schemas.openxmlformats.org/drawingml/2006/chart" r:id="R026ff608eedf46f4"/>
           </a:graphicData>
         </a:graphic>
       </p:graphicFrame>
@@ -15796,6 +16007,7 @@
           <a:lstStyle xmlns:a="http://schemas.openxmlformats.org/drawingml/2006/main"/>
           <a:p xmlns:a="http://schemas.openxmlformats.org/drawingml/2006/main">
             <a:pPr algn="ctr">
+              <a:buNone/>
               <a:defRPr sz="1350" b="1">
                 <a:solidFill>
                   <a:srgbClr val="F8B84E"/>
@@ -15846,6 +16058,7 @@
           <a:lstStyle xmlns:a="http://schemas.openxmlformats.org/drawingml/2006/main"/>
           <a:p xmlns:a="http://schemas.openxmlformats.org/drawingml/2006/main">
             <a:pPr algn="l">
+              <a:buNone/>
               <a:defRPr sz="750" b="1">
                 <a:solidFill>
                   <a:srgbClr val="617984"/>
@@ -15896,6 +16109,7 @@
           <a:lstStyle xmlns:a="http://schemas.openxmlformats.org/drawingml/2006/main"/>
           <a:p xmlns:a="http://schemas.openxmlformats.org/drawingml/2006/main">
             <a:pPr algn="r">
+              <a:buNone/>
               <a:defRPr sz="750" b="1">
                 <a:solidFill>
                   <a:srgbClr val="617984"/>
@@ -15975,6 +16189,7 @@
           <a:lstStyle xmlns:a="http://schemas.openxmlformats.org/drawingml/2006/main"/>
           <a:p xmlns:a="http://schemas.openxmlformats.org/drawingml/2006/main">
             <a:pPr algn="l">
+              <a:buNone/>
               <a:defRPr sz="900" b="1">
                 <a:solidFill>
                   <a:srgbClr val="23D7E6"/>
@@ -16025,6 +16240,7 @@
           <a:lstStyle xmlns:a="http://schemas.openxmlformats.org/drawingml/2006/main"/>
           <a:p xmlns:a="http://schemas.openxmlformats.org/drawingml/2006/main">
             <a:pPr algn="l">
+              <a:buNone/>
               <a:defRPr sz="2700" b="1">
                 <a:solidFill>
                   <a:srgbClr val="EAFBFF"/>
@@ -16077,7 +16293,7 @@
       </p:sp>
       <p:graphicFrame>
         <p:nvGraphicFramePr>
-          <p:cNvPr id="38" name="Chart"/>
+          <p:cNvPr id="40" name="Chart"/>
           <p:cNvGraphicFramePr/>
           <p:nvPr/>
         </p:nvGraphicFramePr>
@@ -16087,7 +16303,7 @@
         </p:xfrm>
         <a:graphic xmlns:a="http://schemas.openxmlformats.org/drawingml/2006/main">
           <a:graphicData uri="http://schemas.openxmlformats.org/drawingml/2006/chart">
-            <c:chart xmlns:r="http://schemas.openxmlformats.org/officeDocument/2006/relationships" xmlns:c="http://schemas.openxmlformats.org/drawingml/2006/chart" r:id="Ra94c04b818cf4deb"/>
+            <c:chart xmlns:r="http://schemas.openxmlformats.org/officeDocument/2006/relationships" xmlns:c="http://schemas.openxmlformats.org/drawingml/2006/chart" r:id="Rc8a39eb0322a44db"/>
           </a:graphicData>
         </a:graphic>
       </p:graphicFrame>
@@ -16124,6 +16340,7 @@
           <a:lstStyle xmlns:a="http://schemas.openxmlformats.org/drawingml/2006/main"/>
           <a:p xmlns:a="http://schemas.openxmlformats.org/drawingml/2006/main">
             <a:pPr algn="l">
+              <a:buNone/>
               <a:defRPr sz="975" b="1">
                 <a:solidFill>
                   <a:srgbClr val="23D7E6"/>
@@ -16174,6 +16391,7 @@
           <a:lstStyle xmlns:a="http://schemas.openxmlformats.org/drawingml/2006/main"/>
           <a:p xmlns:a="http://schemas.openxmlformats.org/drawingml/2006/main">
             <a:pPr algn="l">
+              <a:buNone/>
               <a:defRPr sz="975" b="1">
                 <a:solidFill>
                   <a:srgbClr val="23D7E6"/>
@@ -16224,6 +16442,7 @@
           <a:lstStyle xmlns:a="http://schemas.openxmlformats.org/drawingml/2006/main"/>
           <a:p xmlns:a="http://schemas.openxmlformats.org/drawingml/2006/main">
             <a:pPr algn="l">
+              <a:buNone/>
               <a:defRPr sz="975" b="1">
                 <a:solidFill>
                   <a:srgbClr val="23D7E6"/>
@@ -16307,6 +16526,7 @@
           <a:lstStyle xmlns:a="http://schemas.openxmlformats.org/drawingml/2006/main"/>
           <a:p xmlns:a="http://schemas.openxmlformats.org/drawingml/2006/main">
             <a:pPr algn="l">
+              <a:buNone/>
               <a:defRPr sz="1275" b="1">
                 <a:solidFill>
                   <a:srgbClr val="EAFBFF"/>
@@ -16357,6 +16577,7 @@
           <a:lstStyle xmlns:a="http://schemas.openxmlformats.org/drawingml/2006/main"/>
           <a:p xmlns:a="http://schemas.openxmlformats.org/drawingml/2006/main">
             <a:pPr algn="l">
+              <a:buNone/>
               <a:defRPr sz="1275" b="1">
                 <a:solidFill>
                   <a:srgbClr val="F8B84E"/>
@@ -16407,6 +16628,7 @@
           <a:lstStyle xmlns:a="http://schemas.openxmlformats.org/drawingml/2006/main"/>
           <a:p xmlns:a="http://schemas.openxmlformats.org/drawingml/2006/main">
             <a:pPr algn="l">
+              <a:buNone/>
               <a:defRPr sz="1050" b="0">
                 <a:solidFill>
                   <a:srgbClr val="9DB7C2"/>
@@ -16490,6 +16712,7 @@
           <a:lstStyle xmlns:a="http://schemas.openxmlformats.org/drawingml/2006/main"/>
           <a:p xmlns:a="http://schemas.openxmlformats.org/drawingml/2006/main">
             <a:pPr algn="l">
+              <a:buNone/>
               <a:defRPr sz="1275" b="1">
                 <a:solidFill>
                   <a:srgbClr val="EAFBFF"/>
@@ -16540,6 +16763,7 @@
           <a:lstStyle xmlns:a="http://schemas.openxmlformats.org/drawingml/2006/main"/>
           <a:p xmlns:a="http://schemas.openxmlformats.org/drawingml/2006/main">
             <a:pPr algn="l">
+              <a:buNone/>
               <a:defRPr sz="1275" b="1">
                 <a:solidFill>
                   <a:srgbClr val="F8B84E"/>
@@ -16590,6 +16814,7 @@
           <a:lstStyle xmlns:a="http://schemas.openxmlformats.org/drawingml/2006/main"/>
           <a:p xmlns:a="http://schemas.openxmlformats.org/drawingml/2006/main">
             <a:pPr algn="l">
+              <a:buNone/>
               <a:defRPr sz="1050" b="0">
                 <a:solidFill>
                   <a:srgbClr val="9DB7C2"/>
@@ -16673,6 +16898,7 @@
           <a:lstStyle xmlns:a="http://schemas.openxmlformats.org/drawingml/2006/main"/>
           <a:p xmlns:a="http://schemas.openxmlformats.org/drawingml/2006/main">
             <a:pPr algn="l">
+              <a:buNone/>
               <a:defRPr sz="1275" b="1">
                 <a:solidFill>
                   <a:srgbClr val="EAFBFF"/>
@@ -16723,6 +16949,7 @@
           <a:lstStyle xmlns:a="http://schemas.openxmlformats.org/drawingml/2006/main"/>
           <a:p xmlns:a="http://schemas.openxmlformats.org/drawingml/2006/main">
             <a:pPr algn="l">
+              <a:buNone/>
               <a:defRPr sz="1275" b="1">
                 <a:solidFill>
                   <a:srgbClr val="1AAE9F"/>
@@ -16773,6 +17000,7 @@
           <a:lstStyle xmlns:a="http://schemas.openxmlformats.org/drawingml/2006/main"/>
           <a:p xmlns:a="http://schemas.openxmlformats.org/drawingml/2006/main">
             <a:pPr algn="l">
+              <a:buNone/>
               <a:defRPr sz="1050" b="0">
                 <a:solidFill>
                   <a:srgbClr val="9DB7C2"/>
@@ -16856,6 +17084,7 @@
           <a:lstStyle xmlns:a="http://schemas.openxmlformats.org/drawingml/2006/main"/>
           <a:p xmlns:a="http://schemas.openxmlformats.org/drawingml/2006/main">
             <a:pPr algn="l">
+              <a:buNone/>
               <a:defRPr sz="1275" b="1">
                 <a:solidFill>
                   <a:srgbClr val="EAFBFF"/>
@@ -16906,6 +17135,7 @@
           <a:lstStyle xmlns:a="http://schemas.openxmlformats.org/drawingml/2006/main"/>
           <a:p xmlns:a="http://schemas.openxmlformats.org/drawingml/2006/main">
             <a:pPr algn="l">
+              <a:buNone/>
               <a:defRPr sz="1275" b="1">
                 <a:solidFill>
                   <a:srgbClr val="F8B84E"/>
@@ -16956,6 +17186,7 @@
           <a:lstStyle xmlns:a="http://schemas.openxmlformats.org/drawingml/2006/main"/>
           <a:p xmlns:a="http://schemas.openxmlformats.org/drawingml/2006/main">
             <a:pPr algn="l">
+              <a:buNone/>
               <a:defRPr sz="1050" b="0">
                 <a:solidFill>
                   <a:srgbClr val="9DB7C2"/>
@@ -17039,6 +17270,7 @@
           <a:lstStyle xmlns:a="http://schemas.openxmlformats.org/drawingml/2006/main"/>
           <a:p xmlns:a="http://schemas.openxmlformats.org/drawingml/2006/main">
             <a:pPr algn="l">
+              <a:buNone/>
               <a:defRPr sz="1275" b="1">
                 <a:solidFill>
                   <a:srgbClr val="EAFBFF"/>
@@ -17089,6 +17321,7 @@
           <a:lstStyle xmlns:a="http://schemas.openxmlformats.org/drawingml/2006/main"/>
           <a:p xmlns:a="http://schemas.openxmlformats.org/drawingml/2006/main">
             <a:pPr algn="l">
+              <a:buNone/>
               <a:defRPr sz="1275" b="1">
                 <a:solidFill>
                   <a:srgbClr val="F8B84E"/>
@@ -17139,6 +17372,7 @@
           <a:lstStyle xmlns:a="http://schemas.openxmlformats.org/drawingml/2006/main"/>
           <a:p xmlns:a="http://schemas.openxmlformats.org/drawingml/2006/main">
             <a:pPr algn="l">
+              <a:buNone/>
               <a:defRPr sz="1050" b="0">
                 <a:solidFill>
                   <a:srgbClr val="9DB7C2"/>
@@ -17222,6 +17456,7 @@
           <a:lstStyle xmlns:a="http://schemas.openxmlformats.org/drawingml/2006/main"/>
           <a:p xmlns:a="http://schemas.openxmlformats.org/drawingml/2006/main">
             <a:pPr algn="l">
+              <a:buNone/>
               <a:defRPr sz="1275" b="1">
                 <a:solidFill>
                   <a:srgbClr val="EAFBFF"/>
@@ -17272,6 +17507,7 @@
           <a:lstStyle xmlns:a="http://schemas.openxmlformats.org/drawingml/2006/main"/>
           <a:p xmlns:a="http://schemas.openxmlformats.org/drawingml/2006/main">
             <a:pPr algn="l">
+              <a:buNone/>
               <a:defRPr sz="1275" b="1">
                 <a:solidFill>
                   <a:srgbClr val="F8B84E"/>
@@ -17322,6 +17558,7 @@
           <a:lstStyle xmlns:a="http://schemas.openxmlformats.org/drawingml/2006/main"/>
           <a:p xmlns:a="http://schemas.openxmlformats.org/drawingml/2006/main">
             <a:pPr algn="l">
+              <a:buNone/>
               <a:defRPr sz="1050" b="0">
                 <a:solidFill>
                   <a:srgbClr val="9DB7C2"/>
@@ -17372,6 +17609,7 @@
           <a:lstStyle xmlns:a="http://schemas.openxmlformats.org/drawingml/2006/main"/>
           <a:p xmlns:a="http://schemas.openxmlformats.org/drawingml/2006/main">
             <a:pPr algn="l">
+              <a:buNone/>
               <a:defRPr sz="1200" b="1">
                 <a:solidFill>
                   <a:srgbClr val="F8B84E"/>
@@ -17422,6 +17660,7 @@
           <a:lstStyle xmlns:a="http://schemas.openxmlformats.org/drawingml/2006/main"/>
           <a:p xmlns:a="http://schemas.openxmlformats.org/drawingml/2006/main">
             <a:pPr algn="l">
+              <a:buNone/>
               <a:defRPr sz="750" b="1">
                 <a:solidFill>
                   <a:srgbClr val="617984"/>
@@ -17472,6 +17711,7 @@
           <a:lstStyle xmlns:a="http://schemas.openxmlformats.org/drawingml/2006/main"/>
           <a:p xmlns:a="http://schemas.openxmlformats.org/drawingml/2006/main">
             <a:pPr algn="r">
+              <a:buNone/>
               <a:defRPr sz="750" b="1">
                 <a:solidFill>
                   <a:srgbClr val="617984"/>

</xml_diff>